<commit_message>
Add full facilitator-script presenter notes to Spirituality deck (all 33 slides)
Each slide now carries the full 'say this' script, timings and breakout
instructions in the notes pane (Presenter View). Includes add_notes_spirituality.py
to re-apply notes after regeneration.

Co-Authored-By: Claude Opus 4.8 <noreply@anthropic.com>
Claude-Session: https://claude.ai/code/session_01FhNN1xnUyELSQ3xs2X22yA
</commit_message>
<xml_diff>
--- a/content/sessions/slides/Spirituality-and-Sexuality.pptx
+++ b/content/sessions/slides/Spirituality-and-Sexuality.pptx
@@ -137,6 +137,2666 @@
     </a:lvl9pPr>
   </p:defaultTextStyle>
 </p:presentation>
+</file>
+
+<file path=ppt/notesMasters/notesMaster1.xml><?xml version="1.0" encoding="utf-8"?>
+<p:notesMaster xmlns:a="http://schemas.openxmlformats.org/drawingml/2006/main" xmlns:p="http://schemas.openxmlformats.org/presentationml/2006/main" xmlns:r="http://schemas.openxmlformats.org/officeDocument/2006/relationships">
+  <p:cSld>
+    <p:bg>
+      <p:bgRef idx="1001">
+        <a:schemeClr val="bg1"/>
+      </p:bgRef>
+    </p:bg>
+    <p:spTree>
+      <p:nvGrpSpPr>
+        <p:cNvPr id="1" name=""/>
+        <p:cNvGrpSpPr/>
+        <p:nvPr/>
+      </p:nvGrpSpPr>
+      <p:grpSpPr>
+        <a:xfrm>
+          <a:off x="0" y="0"/>
+          <a:ext cx="0" cy="0"/>
+          <a:chOff x="0" y="0"/>
+          <a:chExt cx="0" cy="0"/>
+        </a:xfrm>
+      </p:grpSpPr>
+      <p:sp>
+        <p:nvSpPr>
+          <p:cNvPr id="2" name="Header Placeholder 1"/>
+          <p:cNvSpPr>
+            <a:spLocks noGrp="1"/>
+          </p:cNvSpPr>
+          <p:nvPr>
+            <p:ph type="hdr" sz="quarter"/>
+          </p:nvPr>
+        </p:nvSpPr>
+        <p:spPr>
+          <a:xfrm>
+            <a:off x="0" y="0"/>
+            <a:ext cx="2971800" cy="457200"/>
+          </a:xfrm>
+          <a:prstGeom prst="rect">
+            <a:avLst/>
+          </a:prstGeom>
+        </p:spPr>
+        <p:txBody>
+          <a:bodyPr vert="horz" lIns="91440" tIns="45720" rIns="91440" bIns="45720" rtlCol="0"/>
+          <a:lstStyle>
+            <a:lvl1pPr algn="l">
+              <a:defRPr sz="1200"/>
+            </a:lvl1pPr>
+          </a:lstStyle>
+          <a:p>
+            <a:endParaRPr lang="en-US"/>
+          </a:p>
+        </p:txBody>
+      </p:sp>
+      <p:sp>
+        <p:nvSpPr>
+          <p:cNvPr id="3" name="Date Placeholder 2"/>
+          <p:cNvSpPr>
+            <a:spLocks noGrp="1"/>
+          </p:cNvSpPr>
+          <p:nvPr>
+            <p:ph type="dt" idx="1"/>
+          </p:nvPr>
+        </p:nvSpPr>
+        <p:spPr>
+          <a:xfrm>
+            <a:off x="3884613" y="0"/>
+            <a:ext cx="2971800" cy="457200"/>
+          </a:xfrm>
+          <a:prstGeom prst="rect">
+            <a:avLst/>
+          </a:prstGeom>
+        </p:spPr>
+        <p:txBody>
+          <a:bodyPr vert="horz" lIns="91440" tIns="45720" rIns="91440" bIns="45720" rtlCol="0"/>
+          <a:lstStyle>
+            <a:lvl1pPr algn="r">
+              <a:defRPr sz="1200"/>
+            </a:lvl1pPr>
+          </a:lstStyle>
+          <a:p>
+            <a:fld id="{0F89C1C7-3DCD-1040-A9CF-14679D8B5DDD}" type="datetimeFigureOut">
+              <a:rPr lang="en-US" smtClean="0"/>
+              <a:t>10/17/16</a:t>
+            </a:fld>
+            <a:endParaRPr lang="en-US"/>
+          </a:p>
+        </p:txBody>
+      </p:sp>
+      <p:sp>
+        <p:nvSpPr>
+          <p:cNvPr id="4" name="Slide Image Placeholder 3"/>
+          <p:cNvSpPr>
+            <a:spLocks noGrp="1" noRot="1" noChangeAspect="1"/>
+          </p:cNvSpPr>
+          <p:nvPr>
+            <p:ph type="sldImg" idx="2"/>
+          </p:nvPr>
+        </p:nvSpPr>
+        <p:spPr>
+          <a:xfrm>
+            <a:off x="1143000" y="685800"/>
+            <a:ext cx="4572000" cy="3429000"/>
+          </a:xfrm>
+          <a:prstGeom prst="rect">
+            <a:avLst/>
+          </a:prstGeom>
+          <a:noFill/>
+          <a:ln w="12700">
+            <a:solidFill>
+              <a:prstClr val="black"/>
+            </a:solidFill>
+          </a:ln>
+        </p:spPr>
+        <p:txBody>
+          <a:bodyPr vert="horz" lIns="91440" tIns="45720" rIns="91440" bIns="45720" rtlCol="0" anchor="ctr"/>
+          <a:lstStyle/>
+          <a:p>
+            <a:endParaRPr lang="en-US"/>
+          </a:p>
+        </p:txBody>
+      </p:sp>
+      <p:sp>
+        <p:nvSpPr>
+          <p:cNvPr id="5" name="Notes Placeholder 4"/>
+          <p:cNvSpPr>
+            <a:spLocks noGrp="1"/>
+          </p:cNvSpPr>
+          <p:nvPr>
+            <p:ph type="body" sz="quarter" idx="3"/>
+          </p:nvPr>
+        </p:nvSpPr>
+        <p:spPr>
+          <a:xfrm>
+            <a:off x="685800" y="4343400"/>
+            <a:ext cx="5486400" cy="4114800"/>
+          </a:xfrm>
+          <a:prstGeom prst="rect">
+            <a:avLst/>
+          </a:prstGeom>
+        </p:spPr>
+        <p:txBody>
+          <a:bodyPr vert="horz" lIns="91440" tIns="45720" rIns="91440" bIns="45720" rtlCol="0"/>
+          <a:lstStyle/>
+          <a:p>
+            <a:pPr lvl="0"/>
+            <a:r>
+              <a:rPr lang="en-US" smtClean="0"/>
+              <a:t>Click to edit Master text styles</a:t>
+            </a:r>
+          </a:p>
+          <a:p>
+            <a:pPr lvl="1"/>
+            <a:r>
+              <a:rPr lang="en-US" smtClean="0"/>
+              <a:t>Second level</a:t>
+            </a:r>
+          </a:p>
+          <a:p>
+            <a:pPr lvl="2"/>
+            <a:r>
+              <a:rPr lang="en-US" smtClean="0"/>
+              <a:t>Third level</a:t>
+            </a:r>
+          </a:p>
+          <a:p>
+            <a:pPr lvl="3"/>
+            <a:r>
+              <a:rPr lang="en-US" smtClean="0"/>
+              <a:t>Fourth level</a:t>
+            </a:r>
+          </a:p>
+          <a:p>
+            <a:pPr lvl="4"/>
+            <a:r>
+              <a:rPr lang="en-US" smtClean="0"/>
+              <a:t>Fifth level</a:t>
+            </a:r>
+            <a:endParaRPr lang="en-US"/>
+          </a:p>
+        </p:txBody>
+      </p:sp>
+      <p:sp>
+        <p:nvSpPr>
+          <p:cNvPr id="6" name="Footer Placeholder 5"/>
+          <p:cNvSpPr>
+            <a:spLocks noGrp="1"/>
+          </p:cNvSpPr>
+          <p:nvPr>
+            <p:ph type="ftr" sz="quarter" idx="4"/>
+          </p:nvPr>
+        </p:nvSpPr>
+        <p:spPr>
+          <a:xfrm>
+            <a:off x="0" y="8685213"/>
+            <a:ext cx="2971800" cy="457200"/>
+          </a:xfrm>
+          <a:prstGeom prst="rect">
+            <a:avLst/>
+          </a:prstGeom>
+        </p:spPr>
+        <p:txBody>
+          <a:bodyPr vert="horz" lIns="91440" tIns="45720" rIns="91440" bIns="45720" rtlCol="0" anchor="b"/>
+          <a:lstStyle>
+            <a:lvl1pPr algn="l">
+              <a:defRPr sz="1200"/>
+            </a:lvl1pPr>
+          </a:lstStyle>
+          <a:p>
+            <a:endParaRPr lang="en-US"/>
+          </a:p>
+        </p:txBody>
+      </p:sp>
+      <p:sp>
+        <p:nvSpPr>
+          <p:cNvPr id="7" name="Slide Number Placeholder 6"/>
+          <p:cNvSpPr>
+            <a:spLocks noGrp="1"/>
+          </p:cNvSpPr>
+          <p:nvPr>
+            <p:ph type="sldNum" sz="quarter" idx="5"/>
+          </p:nvPr>
+        </p:nvSpPr>
+        <p:spPr>
+          <a:xfrm>
+            <a:off x="3884613" y="8685213"/>
+            <a:ext cx="2971800" cy="457200"/>
+          </a:xfrm>
+          <a:prstGeom prst="rect">
+            <a:avLst/>
+          </a:prstGeom>
+        </p:spPr>
+        <p:txBody>
+          <a:bodyPr vert="horz" lIns="91440" tIns="45720" rIns="91440" bIns="45720" rtlCol="0" anchor="b"/>
+          <a:lstStyle>
+            <a:lvl1pPr algn="r">
+              <a:defRPr sz="1200"/>
+            </a:lvl1pPr>
+          </a:lstStyle>
+          <a:p>
+            <a:fld id="{BB5E49A5-4136-284D-997B-48E1D791AD67}" type="slidenum">
+              <a:rPr lang="en-US" smtClean="0"/>
+              <a:t>‹#›</a:t>
+            </a:fld>
+            <a:endParaRPr lang="en-US"/>
+          </a:p>
+        </p:txBody>
+      </p:sp>
+    </p:spTree>
+    <p:extLst>
+      <p:ext uri="{BB962C8B-B14F-4D97-AF65-F5344CB8AC3E}">
+        <p14:creationId xmlns:p14="http://schemas.microsoft.com/office/powerpoint/2010/main" val="2623252185"/>
+      </p:ext>
+    </p:extLst>
+  </p:cSld>
+  <p:clrMap bg1="lt1" tx1="dk1" bg2="lt2" tx2="dk2" accent1="accent1" accent2="accent2" accent3="accent3" accent4="accent4" accent5="accent5" accent6="accent6" hlink="hlink" folHlink="folHlink"/>
+  <p:notesStyle>
+    <a:lvl1pPr marL="0" algn="l" defTabSz="457200" rtl="0" eaLnBrk="1" latinLnBrk="0" hangingPunct="1">
+      <a:defRPr sz="1200" kern="1200">
+        <a:solidFill>
+          <a:schemeClr val="tx1"/>
+        </a:solidFill>
+        <a:latin typeface="+mn-lt"/>
+        <a:ea typeface="+mn-ea"/>
+        <a:cs typeface="+mn-cs"/>
+      </a:defRPr>
+    </a:lvl1pPr>
+    <a:lvl2pPr marL="457200" algn="l" defTabSz="457200" rtl="0" eaLnBrk="1" latinLnBrk="0" hangingPunct="1">
+      <a:defRPr sz="1200" kern="1200">
+        <a:solidFill>
+          <a:schemeClr val="tx1"/>
+        </a:solidFill>
+        <a:latin typeface="+mn-lt"/>
+        <a:ea typeface="+mn-ea"/>
+        <a:cs typeface="+mn-cs"/>
+      </a:defRPr>
+    </a:lvl2pPr>
+    <a:lvl3pPr marL="914400" algn="l" defTabSz="457200" rtl="0" eaLnBrk="1" latinLnBrk="0" hangingPunct="1">
+      <a:defRPr sz="1200" kern="1200">
+        <a:solidFill>
+          <a:schemeClr val="tx1"/>
+        </a:solidFill>
+        <a:latin typeface="+mn-lt"/>
+        <a:ea typeface="+mn-ea"/>
+        <a:cs typeface="+mn-cs"/>
+      </a:defRPr>
+    </a:lvl3pPr>
+    <a:lvl4pPr marL="1371600" algn="l" defTabSz="457200" rtl="0" eaLnBrk="1" latinLnBrk="0" hangingPunct="1">
+      <a:defRPr sz="1200" kern="1200">
+        <a:solidFill>
+          <a:schemeClr val="tx1"/>
+        </a:solidFill>
+        <a:latin typeface="+mn-lt"/>
+        <a:ea typeface="+mn-ea"/>
+        <a:cs typeface="+mn-cs"/>
+      </a:defRPr>
+    </a:lvl4pPr>
+    <a:lvl5pPr marL="1828800" algn="l" defTabSz="457200" rtl="0" eaLnBrk="1" latinLnBrk="0" hangingPunct="1">
+      <a:defRPr sz="1200" kern="1200">
+        <a:solidFill>
+          <a:schemeClr val="tx1"/>
+        </a:solidFill>
+        <a:latin typeface="+mn-lt"/>
+        <a:ea typeface="+mn-ea"/>
+        <a:cs typeface="+mn-cs"/>
+      </a:defRPr>
+    </a:lvl5pPr>
+    <a:lvl6pPr marL="2286000" algn="l" defTabSz="457200" rtl="0" eaLnBrk="1" latinLnBrk="0" hangingPunct="1">
+      <a:defRPr sz="1200" kern="1200">
+        <a:solidFill>
+          <a:schemeClr val="tx1"/>
+        </a:solidFill>
+        <a:latin typeface="+mn-lt"/>
+        <a:ea typeface="+mn-ea"/>
+        <a:cs typeface="+mn-cs"/>
+      </a:defRPr>
+    </a:lvl6pPr>
+    <a:lvl7pPr marL="2743200" algn="l" defTabSz="457200" rtl="0" eaLnBrk="1" latinLnBrk="0" hangingPunct="1">
+      <a:defRPr sz="1200" kern="1200">
+        <a:solidFill>
+          <a:schemeClr val="tx1"/>
+        </a:solidFill>
+        <a:latin typeface="+mn-lt"/>
+        <a:ea typeface="+mn-ea"/>
+        <a:cs typeface="+mn-cs"/>
+      </a:defRPr>
+    </a:lvl7pPr>
+    <a:lvl8pPr marL="3200400" algn="l" defTabSz="457200" rtl="0" eaLnBrk="1" latinLnBrk="0" hangingPunct="1">
+      <a:defRPr sz="1200" kern="1200">
+        <a:solidFill>
+          <a:schemeClr val="tx1"/>
+        </a:solidFill>
+        <a:latin typeface="+mn-lt"/>
+        <a:ea typeface="+mn-ea"/>
+        <a:cs typeface="+mn-cs"/>
+      </a:defRPr>
+    </a:lvl8pPr>
+    <a:lvl9pPr marL="3657600" algn="l" defTabSz="457200" rtl="0" eaLnBrk="1" latinLnBrk="0" hangingPunct="1">
+      <a:defRPr sz="1200" kern="1200">
+        <a:solidFill>
+          <a:schemeClr val="tx1"/>
+        </a:solidFill>
+        <a:latin typeface="+mn-lt"/>
+        <a:ea typeface="+mn-ea"/>
+        <a:cs typeface="+mn-cs"/>
+      </a:defRPr>
+    </a:lvl9pPr>
+  </p:notesStyle>
+</p:notesMaster>
+</file>
+
+<file path=ppt/notesSlides/notesSlide1.xml><?xml version="1.0" encoding="utf-8"?>
+<p:notes xmlns:a="http://schemas.openxmlformats.org/drawingml/2006/main" xmlns:p="http://schemas.openxmlformats.org/presentationml/2006/main" xmlns:r="http://schemas.openxmlformats.org/officeDocument/2006/relationships">
+  <p:cSld>
+    <p:spTree>
+      <p:nvGrpSpPr>
+        <p:cNvPr id="1" name=""/>
+        <p:cNvGrpSpPr/>
+        <p:nvPr/>
+      </p:nvGrpSpPr>
+      <p:grpSpPr>
+        <a:xfrm>
+          <a:off x="0" y="0"/>
+          <a:ext cx="0" cy="0"/>
+          <a:chOff x="0" y="0"/>
+          <a:chExt cx="0" cy="0"/>
+        </a:xfrm>
+      </p:grpSpPr>
+      <p:sp>
+        <p:nvSpPr>
+          <p:cNvPr id="2" name="Slide Image Placeholder 1"/>
+          <p:cNvSpPr>
+            <a:spLocks noGrp="1"/>
+          </p:cNvSpPr>
+          <p:nvPr>
+            <p:ph type="sldImg" idx="2"/>
+          </p:nvPr>
+        </p:nvSpPr>
+        <p:spPr/>
+      </p:sp>
+      <p:sp>
+        <p:nvSpPr>
+          <p:cNvPr id="3" name="Notes Placeholder 2"/>
+          <p:cNvSpPr>
+            <a:spLocks noGrp="1"/>
+          </p:cNvSpPr>
+          <p:nvPr>
+            <p:ph type="body" idx="3" sz="quarter"/>
+          </p:nvPr>
+        </p:nvSpPr>
+        <p:spPr/>
+        <p:txBody>
+          <a:bodyPr/>
+          <a:lstStyle/>
+          <a:p>
+            <a:r>
+              <a:t>Welcome everyone. Light the candle. Read the sacred-space agreements: what's shared here stays here; we witness, we don't fix; you can always pass or slow down; there's no such thing as too much in this room; this is a reverent, judgement-free space. Then settle them: eyes closed, feet on the floor, soften jaw, shoulders, belly, three slow breaths down into the pelvis. 'Tonight we do something most of us were never allowed to do: we treat your body, your pleasure and your desire as holy.' One-word go-round: how are you arriving?</a:t>
+            </a:r>
+          </a:p>
+        </p:txBody>
+      </p:sp>
+      <p:sp>
+        <p:nvSpPr>
+          <p:cNvPr id="4" name="Slide Number Placeholder 3"/>
+          <p:cNvSpPr>
+            <a:spLocks noGrp="1"/>
+          </p:cNvSpPr>
+          <p:nvPr>
+            <p:ph type="sldNum" idx="5" sz="quarter"/>
+          </p:nvPr>
+        </p:nvSpPr>
+        <p:spPr/>
+      </p:sp>
+    </p:spTree>
+  </p:cSld>
+  <p:clrMapOvr>
+    <a:masterClrMapping/>
+  </p:clrMapOvr>
+</p:notes>
+</file>
+
+<file path=ppt/notesSlides/notesSlide10.xml><?xml version="1.0" encoding="utf-8"?>
+<p:notes xmlns:a="http://schemas.openxmlformats.org/drawingml/2006/main" xmlns:p="http://schemas.openxmlformats.org/presentationml/2006/main" xmlns:r="http://schemas.openxmlformats.org/officeDocument/2006/relationships">
+  <p:cSld>
+    <p:spTree>
+      <p:nvGrpSpPr>
+        <p:cNvPr id="1" name=""/>
+        <p:cNvGrpSpPr/>
+        <p:nvPr/>
+      </p:nvGrpSpPr>
+      <p:grpSpPr>
+        <a:xfrm>
+          <a:off x="0" y="0"/>
+          <a:ext cx="0" cy="0"/>
+          <a:chOff x="0" y="0"/>
+          <a:chExt cx="0" cy="0"/>
+        </a:xfrm>
+      </p:grpSpPr>
+      <p:sp>
+        <p:nvSpPr>
+          <p:cNvPr id="2" name="Slide Image Placeholder 1"/>
+          <p:cNvSpPr>
+            <a:spLocks noGrp="1"/>
+          </p:cNvSpPr>
+          <p:nvPr>
+            <p:ph type="sldImg" idx="2"/>
+          </p:nvPr>
+        </p:nvSpPr>
+        <p:spPr/>
+      </p:sp>
+      <p:sp>
+        <p:nvSpPr>
+          <p:cNvPr id="3" name="Notes Placeholder 2"/>
+          <p:cNvSpPr>
+            <a:spLocks noGrp="1"/>
+          </p:cNvSpPr>
+          <p:nvPr>
+            <p:ph type="body" idx="3" sz="quarter"/>
+          </p:nvPr>
+        </p:nvSpPr>
+        <p:spPr/>
+        <p:txBody>
+          <a:bodyPr/>
+          <a:lstStyle/>
+          <a:p>
+            <a:r>
+              <a:t>Pose the reflection questions and let them sit in silence for a moment before the breakout: Where do I feel myself contract or close down? What happens when I try to fix it? What could I open to, even while the contraction is still here?</a:t>
+            </a:r>
+          </a:p>
+        </p:txBody>
+      </p:sp>
+      <p:sp>
+        <p:nvSpPr>
+          <p:cNvPr id="4" name="Slide Number Placeholder 3"/>
+          <p:cNvSpPr>
+            <a:spLocks noGrp="1"/>
+          </p:cNvSpPr>
+          <p:nvPr>
+            <p:ph type="sldNum" idx="5" sz="quarter"/>
+          </p:nvPr>
+        </p:nvSpPr>
+        <p:spPr/>
+      </p:sp>
+    </p:spTree>
+  </p:cSld>
+  <p:clrMapOvr>
+    <a:masterClrMapping/>
+  </p:clrMapOvr>
+</p:notes>
+</file>
+
+<file path=ppt/notesSlides/notesSlide11.xml><?xml version="1.0" encoding="utf-8"?>
+<p:notes xmlns:a="http://schemas.openxmlformats.org/drawingml/2006/main" xmlns:p="http://schemas.openxmlformats.org/presentationml/2006/main" xmlns:r="http://schemas.openxmlformats.org/officeDocument/2006/relationships">
+  <p:cSld>
+    <p:spTree>
+      <p:nvGrpSpPr>
+        <p:cNvPr id="1" name=""/>
+        <p:cNvGrpSpPr/>
+        <p:nvPr/>
+      </p:nvGrpSpPr>
+      <p:grpSpPr>
+        <a:xfrm>
+          <a:off x="0" y="0"/>
+          <a:ext cx="0" cy="0"/>
+          <a:chOff x="0" y="0"/>
+          <a:chExt cx="0" cy="0"/>
+        </a:xfrm>
+      </p:grpSpPr>
+      <p:sp>
+        <p:nvSpPr>
+          <p:cNvPr id="2" name="Slide Image Placeholder 1"/>
+          <p:cNvSpPr>
+            <a:spLocks noGrp="1"/>
+          </p:cNvSpPr>
+          <p:nvPr>
+            <p:ph type="sldImg" idx="2"/>
+          </p:nvPr>
+        </p:nvSpPr>
+        <p:spPr/>
+      </p:sp>
+      <p:sp>
+        <p:nvSpPr>
+          <p:cNvPr id="3" name="Notes Placeholder 2"/>
+          <p:cNvSpPr>
+            <a:spLocks noGrp="1"/>
+          </p:cNvSpPr>
+          <p:nvPr>
+            <p:ph type="body" idx="3" sz="quarter"/>
+          </p:nvPr>
+        </p:nvSpPr>
+        <p:spPr/>
+        <p:txBody>
+          <a:bodyPr/>
+          <a:lstStyle/>
+          <a:p>
+            <a:r>
+              <a:t>Broadcast to the rooms before opening them. In pairs, Partner A for about 6 minutes: 'I feel myself contract or close down when...' / 'What happens when I try to fix it is...' / 'What I could open to, even while it's there, is...' Partner B simply witnesses, no fixing, for them or for themselves. Then swap. Re-broadcast the swap at halfway. Bring everyone back for a one-sentence go-round: 'What I can open to, even while I'm contracted, is...'</a:t>
+            </a:r>
+          </a:p>
+        </p:txBody>
+      </p:sp>
+      <p:sp>
+        <p:nvSpPr>
+          <p:cNvPr id="4" name="Slide Number Placeholder 3"/>
+          <p:cNvSpPr>
+            <a:spLocks noGrp="1"/>
+          </p:cNvSpPr>
+          <p:nvPr>
+            <p:ph type="sldNum" idx="5" sz="quarter"/>
+          </p:nvPr>
+        </p:nvSpPr>
+        <p:spPr/>
+      </p:sp>
+    </p:spTree>
+  </p:cSld>
+  <p:clrMapOvr>
+    <a:masterClrMapping/>
+  </p:clrMapOvr>
+</p:notes>
+</file>
+
+<file path=ppt/notesSlides/notesSlide12.xml><?xml version="1.0" encoding="utf-8"?>
+<p:notes xmlns:a="http://schemas.openxmlformats.org/drawingml/2006/main" xmlns:p="http://schemas.openxmlformats.org/presentationml/2006/main" xmlns:r="http://schemas.openxmlformats.org/officeDocument/2006/relationships">
+  <p:cSld>
+    <p:spTree>
+      <p:nvGrpSpPr>
+        <p:cNvPr id="1" name=""/>
+        <p:cNvGrpSpPr/>
+        <p:nvPr/>
+      </p:nvGrpSpPr>
+      <p:grpSpPr>
+        <a:xfrm>
+          <a:off x="0" y="0"/>
+          <a:ext cx="0" cy="0"/>
+          <a:chOff x="0" y="0"/>
+          <a:chExt cx="0" cy="0"/>
+        </a:xfrm>
+      </p:grpSpPr>
+      <p:sp>
+        <p:nvSpPr>
+          <p:cNvPr id="2" name="Slide Image Placeholder 1"/>
+          <p:cNvSpPr>
+            <a:spLocks noGrp="1"/>
+          </p:cNvSpPr>
+          <p:nvPr>
+            <p:ph type="sldImg" idx="2"/>
+          </p:nvPr>
+        </p:nvSpPr>
+        <p:spPr/>
+      </p:sp>
+      <p:sp>
+        <p:nvSpPr>
+          <p:cNvPr id="3" name="Notes Placeholder 2"/>
+          <p:cNvSpPr>
+            <a:spLocks noGrp="1"/>
+          </p:cNvSpPr>
+          <p:nvPr>
+            <p:ph type="body" idx="3" sz="quarter"/>
+          </p:nvPr>
+        </p:nvSpPr>
+        <p:spPr/>
+        <p:txBody>
+          <a:bodyPr/>
+          <a:lstStyle/>
+          <a:p>
+            <a:r>
+              <a:t>Teach it warmly. Sacred sexuality means bringing intention, presence and reverence to sex, so it becomes more than a physical act. It's a doorway to connection with something larger than yourself, name it however you like: the divine, life force, oneness, love. The act itself doesn't change. The awareness you bring to it does. Approached with presence, sex becomes communion, not performance or transaction.</a:t>
+            </a:r>
+          </a:p>
+        </p:txBody>
+      </p:sp>
+      <p:sp>
+        <p:nvSpPr>
+          <p:cNvPr id="4" name="Slide Number Placeholder 3"/>
+          <p:cNvSpPr>
+            <a:spLocks noGrp="1"/>
+          </p:cNvSpPr>
+          <p:nvPr>
+            <p:ph type="sldNum" idx="5" sz="quarter"/>
+          </p:nvPr>
+        </p:nvSpPr>
+        <p:spPr/>
+      </p:sp>
+    </p:spTree>
+  </p:cSld>
+  <p:clrMapOvr>
+    <a:masterClrMapping/>
+  </p:clrMapOvr>
+</p:notes>
+</file>
+
+<file path=ppt/notesSlides/notesSlide13.xml><?xml version="1.0" encoding="utf-8"?>
+<p:notes xmlns:a="http://schemas.openxmlformats.org/drawingml/2006/main" xmlns:p="http://schemas.openxmlformats.org/presentationml/2006/main" xmlns:r="http://schemas.openxmlformats.org/officeDocument/2006/relationships">
+  <p:cSld>
+    <p:spTree>
+      <p:nvGrpSpPr>
+        <p:cNvPr id="1" name=""/>
+        <p:cNvGrpSpPr/>
+        <p:nvPr/>
+      </p:nvGrpSpPr>
+      <p:grpSpPr>
+        <a:xfrm>
+          <a:off x="0" y="0"/>
+          <a:ext cx="0" cy="0"/>
+          <a:chOff x="0" y="0"/>
+          <a:chExt cx="0" cy="0"/>
+        </a:xfrm>
+      </p:grpSpPr>
+      <p:sp>
+        <p:nvSpPr>
+          <p:cNvPr id="2" name="Slide Image Placeholder 1"/>
+          <p:cNvSpPr>
+            <a:spLocks noGrp="1"/>
+          </p:cNvSpPr>
+          <p:nvPr>
+            <p:ph type="sldImg" idx="2"/>
+          </p:nvPr>
+        </p:nvSpPr>
+        <p:spPr/>
+      </p:sp>
+      <p:sp>
+        <p:nvSpPr>
+          <p:cNvPr id="3" name="Notes Placeholder 2"/>
+          <p:cNvSpPr>
+            <a:spLocks noGrp="1"/>
+          </p:cNvSpPr>
+          <p:nvPr>
+            <p:ph type="body" idx="3" sz="quarter"/>
+          </p:nvPr>
+        </p:nvSpPr>
+        <p:spPr/>
+        <p:txBody>
+          <a:bodyPr/>
+          <a:lstStyle/>
+          <a:p>
+            <a:r>
+              <a:t>How they connect: sexuality and spirituality spring from the same root, desire and longing. Sexuality is the longing to know and be known, to merge with and be met by another, body, heart and soul. Spirituality is that same longing pointed at the whole, to dissolve into and belong to something greater. Two directions, one yearning, to end separateness. That's why the old traditions never split them.</a:t>
+            </a:r>
+          </a:p>
+        </p:txBody>
+      </p:sp>
+      <p:sp>
+        <p:nvSpPr>
+          <p:cNvPr id="4" name="Slide Number Placeholder 3"/>
+          <p:cNvSpPr>
+            <a:spLocks noGrp="1"/>
+          </p:cNvSpPr>
+          <p:nvPr>
+            <p:ph type="sldNum" idx="5" sz="quarter"/>
+          </p:nvPr>
+        </p:nvSpPr>
+        <p:spPr/>
+      </p:sp>
+    </p:spTree>
+  </p:cSld>
+  <p:clrMapOvr>
+    <a:masterClrMapping/>
+  </p:clrMapOvr>
+</p:notes>
+</file>
+
+<file path=ppt/notesSlides/notesSlide14.xml><?xml version="1.0" encoding="utf-8"?>
+<p:notes xmlns:a="http://schemas.openxmlformats.org/drawingml/2006/main" xmlns:p="http://schemas.openxmlformats.org/presentationml/2006/main" xmlns:r="http://schemas.openxmlformats.org/officeDocument/2006/relationships">
+  <p:cSld>
+    <p:spTree>
+      <p:nvGrpSpPr>
+        <p:cNvPr id="1" name=""/>
+        <p:cNvGrpSpPr/>
+        <p:nvPr/>
+      </p:nvGrpSpPr>
+      <p:grpSpPr>
+        <a:xfrm>
+          <a:off x="0" y="0"/>
+          <a:ext cx="0" cy="0"/>
+          <a:chOff x="0" y="0"/>
+          <a:chExt cx="0" cy="0"/>
+        </a:xfrm>
+      </p:grpSpPr>
+      <p:sp>
+        <p:nvSpPr>
+          <p:cNvPr id="2" name="Slide Image Placeholder 1"/>
+          <p:cNvSpPr>
+            <a:spLocks noGrp="1"/>
+          </p:cNvSpPr>
+          <p:nvPr>
+            <p:ph type="sldImg" idx="2"/>
+          </p:nvPr>
+        </p:nvSpPr>
+        <p:spPr/>
+      </p:sp>
+      <p:sp>
+        <p:nvSpPr>
+          <p:cNvPr id="3" name="Notes Placeholder 2"/>
+          <p:cNvSpPr>
+            <a:spLocks noGrp="1"/>
+          </p:cNvSpPr>
+          <p:nvPr>
+            <p:ph type="body" idx="3" sz="quarter"/>
+          </p:nvPr>
+        </p:nvSpPr>
+        <p:spPr/>
+        <p:txBody>
+          <a:bodyPr/>
+          <a:lstStyle/>
+          <a:p>
+            <a:r>
+              <a:t>Tantra never split body and spirit. The Western split, body shameful, spirit holy, is the wound, not the truth. Transcendence, like pleasure, moves through the body, not around it. You reach the sacred by going into the body, not by rising above it. This is exactly why bypassing can't get you there.</a:t>
+            </a:r>
+          </a:p>
+        </p:txBody>
+      </p:sp>
+      <p:sp>
+        <p:nvSpPr>
+          <p:cNvPr id="4" name="Slide Number Placeholder 3"/>
+          <p:cNvSpPr>
+            <a:spLocks noGrp="1"/>
+          </p:cNvSpPr>
+          <p:nvPr>
+            <p:ph type="sldNum" idx="5" sz="quarter"/>
+          </p:nvPr>
+        </p:nvSpPr>
+        <p:spPr/>
+      </p:sp>
+    </p:spTree>
+  </p:cSld>
+  <p:clrMapOvr>
+    <a:masterClrMapping/>
+  </p:clrMapOvr>
+</p:notes>
+</file>
+
+<file path=ppt/notesSlides/notesSlide15.xml><?xml version="1.0" encoding="utf-8"?>
+<p:notes xmlns:a="http://schemas.openxmlformats.org/drawingml/2006/main" xmlns:p="http://schemas.openxmlformats.org/presentationml/2006/main" xmlns:r="http://schemas.openxmlformats.org/officeDocument/2006/relationships">
+  <p:cSld>
+    <p:spTree>
+      <p:nvGrpSpPr>
+        <p:cNvPr id="1" name=""/>
+        <p:cNvGrpSpPr/>
+        <p:nvPr/>
+      </p:nvGrpSpPr>
+      <p:grpSpPr>
+        <a:xfrm>
+          <a:off x="0" y="0"/>
+          <a:ext cx="0" cy="0"/>
+          <a:chOff x="0" y="0"/>
+          <a:chExt cx="0" cy="0"/>
+        </a:xfrm>
+      </p:grpSpPr>
+      <p:sp>
+        <p:nvSpPr>
+          <p:cNvPr id="2" name="Slide Image Placeholder 1"/>
+          <p:cNvSpPr>
+            <a:spLocks noGrp="1"/>
+          </p:cNvSpPr>
+          <p:nvPr>
+            <p:ph type="sldImg" idx="2"/>
+          </p:nvPr>
+        </p:nvSpPr>
+        <p:spPr/>
+      </p:sp>
+      <p:sp>
+        <p:nvSpPr>
+          <p:cNvPr id="3" name="Notes Placeholder 2"/>
+          <p:cNvSpPr>
+            <a:spLocks noGrp="1"/>
+          </p:cNvSpPr>
+          <p:nvPr>
+            <p:ph type="body" idx="3" sz="quarter"/>
+          </p:nvPr>
+        </p:nvSpPr>
+        <p:spPr/>
+        <p:txBody>
+          <a:bodyPr/>
+          <a:lstStyle/>
+          <a:p>
+            <a:r>
+              <a:t>Open the evidence: this isn't wishful thinking. Dr Lori Brotto's clinical studies show mindfulness, simply being present in the body, measurably improves women's desire, arousal and satisfaction, held at six-month follow-up. The spiritual muscle and the sexual muscle are the same muscle: presence. And presence is trainable.</a:t>
+            </a:r>
+          </a:p>
+        </p:txBody>
+      </p:sp>
+      <p:sp>
+        <p:nvSpPr>
+          <p:cNvPr id="4" name="Slide Number Placeholder 3"/>
+          <p:cNvSpPr>
+            <a:spLocks noGrp="1"/>
+          </p:cNvSpPr>
+          <p:nvPr>
+            <p:ph type="sldNum" idx="5" sz="quarter"/>
+          </p:nvPr>
+        </p:nvSpPr>
+        <p:spPr/>
+      </p:sp>
+    </p:spTree>
+  </p:cSld>
+  <p:clrMapOvr>
+    <a:masterClrMapping/>
+  </p:clrMapOvr>
+</p:notes>
+</file>
+
+<file path=ppt/notesSlides/notesSlide16.xml><?xml version="1.0" encoding="utf-8"?>
+<p:notes xmlns:a="http://schemas.openxmlformats.org/drawingml/2006/main" xmlns:p="http://schemas.openxmlformats.org/presentationml/2006/main" xmlns:r="http://schemas.openxmlformats.org/officeDocument/2006/relationships">
+  <p:cSld>
+    <p:spTree>
+      <p:nvGrpSpPr>
+        <p:cNvPr id="1" name=""/>
+        <p:cNvGrpSpPr/>
+        <p:nvPr/>
+      </p:nvGrpSpPr>
+      <p:grpSpPr>
+        <a:xfrm>
+          <a:off x="0" y="0"/>
+          <a:ext cx="0" cy="0"/>
+          <a:chOff x="0" y="0"/>
+          <a:chExt cx="0" cy="0"/>
+        </a:xfrm>
+      </p:grpSpPr>
+      <p:sp>
+        <p:nvSpPr>
+          <p:cNvPr id="2" name="Slide Image Placeholder 1"/>
+          <p:cNvSpPr>
+            <a:spLocks noGrp="1"/>
+          </p:cNvSpPr>
+          <p:nvPr>
+            <p:ph type="sldImg" idx="2"/>
+          </p:nvPr>
+        </p:nvSpPr>
+        <p:spPr/>
+      </p:sp>
+      <p:sp>
+        <p:nvSpPr>
+          <p:cNvPr id="3" name="Notes Placeholder 2"/>
+          <p:cNvSpPr>
+            <a:spLocks noGrp="1"/>
+          </p:cNvSpPr>
+          <p:nvPr>
+            <p:ph type="body" idx="3" sz="quarter"/>
+          </p:nvPr>
+        </p:nvSpPr>
+        <p:spPr/>
+        <p:txBody>
+          <a:bodyPr/>
+          <a:lstStyle/>
+          <a:p>
+            <a:r>
+              <a:t>In studies of mutual eye gaze, two people's brain activity, and even their blinking, begin to synchronise, and they feel measurably closer. 'Becoming one' isn't only poetry, there's a biology to it. This is why eye gazing is in the practices.</a:t>
+            </a:r>
+          </a:p>
+        </p:txBody>
+      </p:sp>
+      <p:sp>
+        <p:nvSpPr>
+          <p:cNvPr id="4" name="Slide Number Placeholder 3"/>
+          <p:cNvSpPr>
+            <a:spLocks noGrp="1"/>
+          </p:cNvSpPr>
+          <p:nvPr>
+            <p:ph type="sldNum" idx="5" sz="quarter"/>
+          </p:nvPr>
+        </p:nvSpPr>
+        <p:spPr/>
+      </p:sp>
+    </p:spTree>
+  </p:cSld>
+  <p:clrMapOvr>
+    <a:masterClrMapping/>
+  </p:clrMapOvr>
+</p:notes>
+</file>
+
+<file path=ppt/notesSlides/notesSlide17.xml><?xml version="1.0" encoding="utf-8"?>
+<p:notes xmlns:a="http://schemas.openxmlformats.org/drawingml/2006/main" xmlns:p="http://schemas.openxmlformats.org/presentationml/2006/main" xmlns:r="http://schemas.openxmlformats.org/officeDocument/2006/relationships">
+  <p:cSld>
+    <p:spTree>
+      <p:nvGrpSpPr>
+        <p:cNvPr id="1" name=""/>
+        <p:cNvGrpSpPr/>
+        <p:nvPr/>
+      </p:nvGrpSpPr>
+      <p:grpSpPr>
+        <a:xfrm>
+          <a:off x="0" y="0"/>
+          <a:ext cx="0" cy="0"/>
+          <a:chOff x="0" y="0"/>
+          <a:chExt cx="0" cy="0"/>
+        </a:xfrm>
+      </p:grpSpPr>
+      <p:sp>
+        <p:nvSpPr>
+          <p:cNvPr id="2" name="Slide Image Placeholder 1"/>
+          <p:cNvSpPr>
+            <a:spLocks noGrp="1"/>
+          </p:cNvSpPr>
+          <p:nvPr>
+            <p:ph type="sldImg" idx="2"/>
+          </p:nvPr>
+        </p:nvSpPr>
+        <p:spPr/>
+      </p:sp>
+      <p:sp>
+        <p:nvSpPr>
+          <p:cNvPr id="3" name="Notes Placeholder 2"/>
+          <p:cNvSpPr>
+            <a:spLocks noGrp="1"/>
+          </p:cNvSpPr>
+          <p:nvPr>
+            <p:ph type="body" idx="3" sz="quarter"/>
+          </p:nvPr>
+        </p:nvSpPr>
+        <p:spPr/>
+        <p:txBody>
+          <a:bodyPr/>
+          <a:lstStyle/>
+          <a:p>
+            <a:r>
+              <a:t>Touch and intimacy release oxytocin, dopamine and endorphins: bonding, trust, dissolved boundaries, the afterglow. That merged, spacious, melted feeling women describe has a real chemistry. Connection literally soothes the nervous system.</a:t>
+            </a:r>
+          </a:p>
+        </p:txBody>
+      </p:sp>
+      <p:sp>
+        <p:nvSpPr>
+          <p:cNvPr id="4" name="Slide Number Placeholder 3"/>
+          <p:cNvSpPr>
+            <a:spLocks noGrp="1"/>
+          </p:cNvSpPr>
+          <p:nvPr>
+            <p:ph type="sldNum" idx="5" sz="quarter"/>
+          </p:nvPr>
+        </p:nvSpPr>
+        <p:spPr/>
+      </p:sp>
+    </p:spTree>
+  </p:cSld>
+  <p:clrMapOvr>
+    <a:masterClrMapping/>
+  </p:clrMapOvr>
+</p:notes>
+</file>
+
+<file path=ppt/notesSlides/notesSlide18.xml><?xml version="1.0" encoding="utf-8"?>
+<p:notes xmlns:a="http://schemas.openxmlformats.org/drawingml/2006/main" xmlns:p="http://schemas.openxmlformats.org/presentationml/2006/main" xmlns:r="http://schemas.openxmlformats.org/officeDocument/2006/relationships">
+  <p:cSld>
+    <p:spTree>
+      <p:nvGrpSpPr>
+        <p:cNvPr id="1" name=""/>
+        <p:cNvGrpSpPr/>
+        <p:nvPr/>
+      </p:nvGrpSpPr>
+      <p:grpSpPr>
+        <a:xfrm>
+          <a:off x="0" y="0"/>
+          <a:ext cx="0" cy="0"/>
+          <a:chOff x="0" y="0"/>
+          <a:chExt cx="0" cy="0"/>
+        </a:xfrm>
+      </p:grpSpPr>
+      <p:sp>
+        <p:nvSpPr>
+          <p:cNvPr id="2" name="Slide Image Placeholder 1"/>
+          <p:cNvSpPr>
+            <a:spLocks noGrp="1"/>
+          </p:cNvSpPr>
+          <p:nvPr>
+            <p:ph type="sldImg" idx="2"/>
+          </p:nvPr>
+        </p:nvSpPr>
+        <p:spPr/>
+      </p:sp>
+      <p:sp>
+        <p:nvSpPr>
+          <p:cNvPr id="3" name="Notes Placeholder 2"/>
+          <p:cNvSpPr>
+            <a:spLocks noGrp="1"/>
+          </p:cNvSpPr>
+          <p:nvPr>
+            <p:ph type="body" idx="3" sz="quarter"/>
+          </p:nvPr>
+        </p:nvSpPr>
+        <p:spPr/>
+        <p:txBody>
+          <a:bodyPr/>
+          <a:lstStyle/>
+          <a:p>
+            <a:r>
+              <a:t>Research ties being truly seen to the deepest connection, the very vulnerability the spiritual traditions call surrender. Letting yourself be seen is both the sexual and the spiritual doorway.</a:t>
+            </a:r>
+          </a:p>
+        </p:txBody>
+      </p:sp>
+      <p:sp>
+        <p:nvSpPr>
+          <p:cNvPr id="4" name="Slide Number Placeholder 3"/>
+          <p:cNvSpPr>
+            <a:spLocks noGrp="1"/>
+          </p:cNvSpPr>
+          <p:nvPr>
+            <p:ph type="sldNum" idx="5" sz="quarter"/>
+          </p:nvPr>
+        </p:nvSpPr>
+        <p:spPr/>
+      </p:sp>
+    </p:spTree>
+  </p:cSld>
+  <p:clrMapOvr>
+    <a:masterClrMapping/>
+  </p:clrMapOvr>
+</p:notes>
+</file>
+
+<file path=ppt/notesSlides/notesSlide19.xml><?xml version="1.0" encoding="utf-8"?>
+<p:notes xmlns:a="http://schemas.openxmlformats.org/drawingml/2006/main" xmlns:p="http://schemas.openxmlformats.org/presentationml/2006/main" xmlns:r="http://schemas.openxmlformats.org/officeDocument/2006/relationships">
+  <p:cSld>
+    <p:spTree>
+      <p:nvGrpSpPr>
+        <p:cNvPr id="1" name=""/>
+        <p:cNvGrpSpPr/>
+        <p:nvPr/>
+      </p:nvGrpSpPr>
+      <p:grpSpPr>
+        <a:xfrm>
+          <a:off x="0" y="0"/>
+          <a:ext cx="0" cy="0"/>
+          <a:chOff x="0" y="0"/>
+          <a:chExt cx="0" cy="0"/>
+        </a:xfrm>
+      </p:grpSpPr>
+      <p:sp>
+        <p:nvSpPr>
+          <p:cNvPr id="2" name="Slide Image Placeholder 1"/>
+          <p:cNvSpPr>
+            <a:spLocks noGrp="1"/>
+          </p:cNvSpPr>
+          <p:nvPr>
+            <p:ph type="sldImg" idx="2"/>
+          </p:nvPr>
+        </p:nvSpPr>
+        <p:spPr/>
+      </p:sp>
+      <p:sp>
+        <p:nvSpPr>
+          <p:cNvPr id="3" name="Notes Placeholder 2"/>
+          <p:cNvSpPr>
+            <a:spLocks noGrp="1"/>
+          </p:cNvSpPr>
+          <p:nvPr>
+            <p:ph type="body" idx="3" sz="quarter"/>
+          </p:nvPr>
+        </p:nvSpPr>
+        <p:spPr/>
+        <p:txBody>
+          <a:bodyPr/>
+          <a:lstStyle/>
+          <a:p>
+            <a:r>
+              <a:t>Bridge it all together. Received as a gift, not a project to fix, and trusted as your guidance, your body isn't the obstacle to the sacred. It's the doorway. A gift is received, not earned. That's the posture of both pleasure and the sacred.</a:t>
+            </a:r>
+          </a:p>
+        </p:txBody>
+      </p:sp>
+      <p:sp>
+        <p:nvSpPr>
+          <p:cNvPr id="4" name="Slide Number Placeholder 3"/>
+          <p:cNvSpPr>
+            <a:spLocks noGrp="1"/>
+          </p:cNvSpPr>
+          <p:nvPr>
+            <p:ph type="sldNum" idx="5" sz="quarter"/>
+          </p:nvPr>
+        </p:nvSpPr>
+        <p:spPr/>
+      </p:sp>
+    </p:spTree>
+  </p:cSld>
+  <p:clrMapOvr>
+    <a:masterClrMapping/>
+  </p:clrMapOvr>
+</p:notes>
+</file>
+
+<file path=ppt/notesSlides/notesSlide2.xml><?xml version="1.0" encoding="utf-8"?>
+<p:notes xmlns:a="http://schemas.openxmlformats.org/drawingml/2006/main" xmlns:p="http://schemas.openxmlformats.org/presentationml/2006/main" xmlns:r="http://schemas.openxmlformats.org/officeDocument/2006/relationships">
+  <p:cSld>
+    <p:spTree>
+      <p:nvGrpSpPr>
+        <p:cNvPr id="1" name=""/>
+        <p:cNvGrpSpPr/>
+        <p:nvPr/>
+      </p:nvGrpSpPr>
+      <p:grpSpPr>
+        <a:xfrm>
+          <a:off x="0" y="0"/>
+          <a:ext cx="0" cy="0"/>
+          <a:chOff x="0" y="0"/>
+          <a:chExt cx="0" cy="0"/>
+        </a:xfrm>
+      </p:grpSpPr>
+      <p:sp>
+        <p:nvSpPr>
+          <p:cNvPr id="2" name="Slide Image Placeholder 1"/>
+          <p:cNvSpPr>
+            <a:spLocks noGrp="1"/>
+          </p:cNvSpPr>
+          <p:nvPr>
+            <p:ph type="sldImg" idx="2"/>
+          </p:nvPr>
+        </p:nvSpPr>
+        <p:spPr/>
+      </p:sp>
+      <p:sp>
+        <p:nvSpPr>
+          <p:cNvPr id="3" name="Notes Placeholder 2"/>
+          <p:cNvSpPr>
+            <a:spLocks noGrp="1"/>
+          </p:cNvSpPr>
+          <p:nvPr>
+            <p:ph type="body" idx="3" sz="quarter"/>
+          </p:nvPr>
+        </p:nvSpPr>
+        <p:spPr/>
+        <p:txBody>
+          <a:bodyPr/>
+          <a:lstStyle/>
+          <a:p>
+            <a:r>
+              <a:t>We always begin here. Say it simply: you can't open to anything bigger while you're at war with yourself. So before anything else, we come home to ourselves with kindness.</a:t>
+            </a:r>
+          </a:p>
+        </p:txBody>
+      </p:sp>
+      <p:sp>
+        <p:nvSpPr>
+          <p:cNvPr id="4" name="Slide Number Placeholder 3"/>
+          <p:cNvSpPr>
+            <a:spLocks noGrp="1"/>
+          </p:cNvSpPr>
+          <p:nvPr>
+            <p:ph type="sldNum" idx="5" sz="quarter"/>
+          </p:nvPr>
+        </p:nvSpPr>
+        <p:spPr/>
+      </p:sp>
+    </p:spTree>
+  </p:cSld>
+  <p:clrMapOvr>
+    <a:masterClrMapping/>
+  </p:clrMapOvr>
+</p:notes>
+</file>
+
+<file path=ppt/notesSlides/notesSlide20.xml><?xml version="1.0" encoding="utf-8"?>
+<p:notes xmlns:a="http://schemas.openxmlformats.org/drawingml/2006/main" xmlns:p="http://schemas.openxmlformats.org/presentationml/2006/main" xmlns:r="http://schemas.openxmlformats.org/officeDocument/2006/relationships">
+  <p:cSld>
+    <p:spTree>
+      <p:nvGrpSpPr>
+        <p:cNvPr id="1" name=""/>
+        <p:cNvGrpSpPr/>
+        <p:nvPr/>
+      </p:nvGrpSpPr>
+      <p:grpSpPr>
+        <a:xfrm>
+          <a:off x="0" y="0"/>
+          <a:ext cx="0" cy="0"/>
+          <a:chOff x="0" y="0"/>
+          <a:chExt cx="0" cy="0"/>
+        </a:xfrm>
+      </p:grpSpPr>
+      <p:sp>
+        <p:nvSpPr>
+          <p:cNvPr id="2" name="Slide Image Placeholder 1"/>
+          <p:cNvSpPr>
+            <a:spLocks noGrp="1"/>
+          </p:cNvSpPr>
+          <p:nvPr>
+            <p:ph type="sldImg" idx="2"/>
+          </p:nvPr>
+        </p:nvSpPr>
+        <p:spPr/>
+      </p:sp>
+      <p:sp>
+        <p:nvSpPr>
+          <p:cNvPr id="3" name="Notes Placeholder 2"/>
+          <p:cNvSpPr>
+            <a:spLocks noGrp="1"/>
+          </p:cNvSpPr>
+          <p:nvPr>
+            <p:ph type="body" idx="3" sz="quarter"/>
+          </p:nvPr>
+        </p:nvSpPr>
+        <p:spPr/>
+        <p:txBody>
+          <a:bodyPr/>
+          <a:lstStyle/>
+          <a:p>
+            <a:r>
+              <a:t>Guide slowly, cameras optional. 'Both feet on the floor. One hand on your heart, one hand low on your belly. Breathe down, long and slow, into your womb space, the seat of your life force. Breathe in warmth. Breathe out, and if you feel yourself contract, let it be there, you're not making it leave, you're just opening, breath by breath, to something bigger. Now move your hands slowly, honouring your body. As you touch each part, thank her: what do your hands do for you, your hips, your belly? Send each part gratitude and love. Silently: I'm here. I love you. Thank you.' Pleasure opens in a body that feels adored.</a:t>
+            </a:r>
+          </a:p>
+        </p:txBody>
+      </p:sp>
+      <p:sp>
+        <p:nvSpPr>
+          <p:cNvPr id="4" name="Slide Number Placeholder 3"/>
+          <p:cNvSpPr>
+            <a:spLocks noGrp="1"/>
+          </p:cNvSpPr>
+          <p:nvPr>
+            <p:ph type="sldNum" idx="5" sz="quarter"/>
+          </p:nvPr>
+        </p:nvSpPr>
+        <p:spPr/>
+      </p:sp>
+    </p:spTree>
+  </p:cSld>
+  <p:clrMapOvr>
+    <a:masterClrMapping/>
+  </p:clrMapOvr>
+</p:notes>
+</file>
+
+<file path=ppt/notesSlides/notesSlide21.xml><?xml version="1.0" encoding="utf-8"?>
+<p:notes xmlns:a="http://schemas.openxmlformats.org/drawingml/2006/main" xmlns:p="http://schemas.openxmlformats.org/presentationml/2006/main" xmlns:r="http://schemas.openxmlformats.org/officeDocument/2006/relationships">
+  <p:cSld>
+    <p:spTree>
+      <p:nvGrpSpPr>
+        <p:cNvPr id="1" name=""/>
+        <p:cNvGrpSpPr/>
+        <p:nvPr/>
+      </p:nvGrpSpPr>
+      <p:grpSpPr>
+        <a:xfrm>
+          <a:off x="0" y="0"/>
+          <a:ext cx="0" cy="0"/>
+          <a:chOff x="0" y="0"/>
+          <a:chExt cx="0" cy="0"/>
+        </a:xfrm>
+      </p:grpSpPr>
+      <p:sp>
+        <p:nvSpPr>
+          <p:cNvPr id="2" name="Slide Image Placeholder 1"/>
+          <p:cNvSpPr>
+            <a:spLocks noGrp="1"/>
+          </p:cNvSpPr>
+          <p:nvPr>
+            <p:ph type="sldImg" idx="2"/>
+          </p:nvPr>
+        </p:nvSpPr>
+        <p:spPr/>
+      </p:sp>
+      <p:sp>
+        <p:nvSpPr>
+          <p:cNvPr id="3" name="Notes Placeholder 2"/>
+          <p:cNvSpPr>
+            <a:spLocks noGrp="1"/>
+          </p:cNvSpPr>
+          <p:nvPr>
+            <p:ph type="body" idx="3" sz="quarter"/>
+          </p:nvPr>
+        </p:nvSpPr>
+        <p:spPr/>
+        <p:txBody>
+          <a:bodyPr/>
+          <a:lstStyle/>
+          <a:p>
+            <a:r>
+              <a:t>Pose first: what pleasure did I stop letting myself feel, and what would it mean to give it back? Then broadcast. In pairs, Partner A for about 6 minutes: 'A pleasure I stopped letting myself feel is...' / 'One small, sacred pleasure I could give myself this week is...' / 'The part of my body I'm ready to make peace with is...' Partner B witnesses with warmth. Swap. Main-room: name the one sacred pleasure you're claiming this week.</a:t>
+            </a:r>
+          </a:p>
+        </p:txBody>
+      </p:sp>
+      <p:sp>
+        <p:nvSpPr>
+          <p:cNvPr id="4" name="Slide Number Placeholder 3"/>
+          <p:cNvSpPr>
+            <a:spLocks noGrp="1"/>
+          </p:cNvSpPr>
+          <p:nvPr>
+            <p:ph type="sldNum" idx="5" sz="quarter"/>
+          </p:nvPr>
+        </p:nvSpPr>
+        <p:spPr/>
+      </p:sp>
+    </p:spTree>
+  </p:cSld>
+  <p:clrMapOvr>
+    <a:masterClrMapping/>
+  </p:clrMapOvr>
+</p:notes>
+</file>
+
+<file path=ppt/notesSlides/notesSlide22.xml><?xml version="1.0" encoding="utf-8"?>
+<p:notes xmlns:a="http://schemas.openxmlformats.org/drawingml/2006/main" xmlns:p="http://schemas.openxmlformats.org/presentationml/2006/main" xmlns:r="http://schemas.openxmlformats.org/officeDocument/2006/relationships">
+  <p:cSld>
+    <p:spTree>
+      <p:nvGrpSpPr>
+        <p:cNvPr id="1" name=""/>
+        <p:cNvGrpSpPr/>
+        <p:nvPr/>
+      </p:nvGrpSpPr>
+      <p:grpSpPr>
+        <a:xfrm>
+          <a:off x="0" y="0"/>
+          <a:ext cx="0" cy="0"/>
+          <a:chOff x="0" y="0"/>
+          <a:chExt cx="0" cy="0"/>
+        </a:xfrm>
+      </p:grpSpPr>
+      <p:sp>
+        <p:nvSpPr>
+          <p:cNvPr id="2" name="Slide Image Placeholder 1"/>
+          <p:cNvSpPr>
+            <a:spLocks noGrp="1"/>
+          </p:cNvSpPr>
+          <p:nvPr>
+            <p:ph type="sldImg" idx="2"/>
+          </p:nvPr>
+        </p:nvSpPr>
+        <p:spPr/>
+      </p:sp>
+      <p:sp>
+        <p:nvSpPr>
+          <p:cNvPr id="3" name="Notes Placeholder 2"/>
+          <p:cNvSpPr>
+            <a:spLocks noGrp="1"/>
+          </p:cNvSpPr>
+          <p:nvPr>
+            <p:ph type="body" idx="3" sz="quarter"/>
+          </p:nvPr>
+        </p:nvSpPr>
+        <p:spPr/>
+        <p:txBody>
+          <a:bodyPr/>
+          <a:lstStyle/>
+          <a:p>
+            <a:r>
+              <a:t>Send them off. Each day this week, ten minutes: light a candle, hand on heart and hand on belly, breathe into the body and say 'I'm here. I love you. Thank you.' Then do one small thing that treats the body as sacred, a slow bath, silk on the skin, moving to music, dressing for no one but yourself. Closing round, one line each: 'The way I'll honour my body this week is...' Circle answers: 'She is sacred.' Blow out the candle together.</a:t>
+            </a:r>
+          </a:p>
+        </p:txBody>
+      </p:sp>
+      <p:sp>
+        <p:nvSpPr>
+          <p:cNvPr id="4" name="Slide Number Placeholder 3"/>
+          <p:cNvSpPr>
+            <a:spLocks noGrp="1"/>
+          </p:cNvSpPr>
+          <p:nvPr>
+            <p:ph type="sldNum" idx="5" sz="quarter"/>
+          </p:nvPr>
+        </p:nvSpPr>
+        <p:spPr/>
+      </p:sp>
+    </p:spTree>
+  </p:cSld>
+  <p:clrMapOvr>
+    <a:masterClrMapping/>
+  </p:clrMapOvr>
+</p:notes>
+</file>
+
+<file path=ppt/notesSlides/notesSlide23.xml><?xml version="1.0" encoding="utf-8"?>
+<p:notes xmlns:a="http://schemas.openxmlformats.org/drawingml/2006/main" xmlns:p="http://schemas.openxmlformats.org/presentationml/2006/main" xmlns:r="http://schemas.openxmlformats.org/officeDocument/2006/relationships">
+  <p:cSld>
+    <p:spTree>
+      <p:nvGrpSpPr>
+        <p:cNvPr id="1" name=""/>
+        <p:cNvGrpSpPr/>
+        <p:nvPr/>
+      </p:nvGrpSpPr>
+      <p:grpSpPr>
+        <a:xfrm>
+          <a:off x="0" y="0"/>
+          <a:ext cx="0" cy="0"/>
+          <a:chOff x="0" y="0"/>
+          <a:chExt cx="0" cy="0"/>
+        </a:xfrm>
+      </p:grpSpPr>
+      <p:sp>
+        <p:nvSpPr>
+          <p:cNvPr id="2" name="Slide Image Placeholder 1"/>
+          <p:cNvSpPr>
+            <a:spLocks noGrp="1"/>
+          </p:cNvSpPr>
+          <p:nvPr>
+            <p:ph type="sldImg" idx="2"/>
+          </p:nvPr>
+        </p:nvSpPr>
+        <p:spPr/>
+      </p:sp>
+      <p:sp>
+        <p:nvSpPr>
+          <p:cNvPr id="3" name="Notes Placeholder 2"/>
+          <p:cNvSpPr>
+            <a:spLocks noGrp="1"/>
+          </p:cNvSpPr>
+          <p:nvPr>
+            <p:ph type="body" idx="3" sz="quarter"/>
+          </p:nvPr>
+        </p:nvSpPr>
+        <p:spPr/>
+        <p:txBody>
+          <a:bodyPr/>
+          <a:lstStyle/>
+          <a:p>
+            <a:r>
+              <a:t>Session 2. Soften them in as before, then recap the ground: last time we made the body sacred again; tonight we bring that reverence to connection; safety first, always, sacred union begins with your own yes. Go-round: one way I honoured my body this week. Pose the reflection questions for later: When do I feel truly safe and connected? What do I long for that I've never said out loud? What helps me stay present instead of performing?</a:t>
+            </a:r>
+          </a:p>
+        </p:txBody>
+      </p:sp>
+      <p:sp>
+        <p:nvSpPr>
+          <p:cNvPr id="4" name="Slide Number Placeholder 3"/>
+          <p:cNvSpPr>
+            <a:spLocks noGrp="1"/>
+          </p:cNvSpPr>
+          <p:nvPr>
+            <p:ph type="sldNum" idx="5" sz="quarter"/>
+          </p:nvPr>
+        </p:nvSpPr>
+        <p:spPr/>
+      </p:sp>
+    </p:spTree>
+  </p:cSld>
+  <p:clrMapOvr>
+    <a:masterClrMapping/>
+  </p:clrMapOvr>
+</p:notes>
+</file>
+
+<file path=ppt/notesSlides/notesSlide24.xml><?xml version="1.0" encoding="utf-8"?>
+<p:notes xmlns:a="http://schemas.openxmlformats.org/drawingml/2006/main" xmlns:p="http://schemas.openxmlformats.org/presentationml/2006/main" xmlns:r="http://schemas.openxmlformats.org/officeDocument/2006/relationships">
+  <p:cSld>
+    <p:spTree>
+      <p:nvGrpSpPr>
+        <p:cNvPr id="1" name=""/>
+        <p:cNvGrpSpPr/>
+        <p:nvPr/>
+      </p:nvGrpSpPr>
+      <p:grpSpPr>
+        <a:xfrm>
+          <a:off x="0" y="0"/>
+          <a:ext cx="0" cy="0"/>
+          <a:chOff x="0" y="0"/>
+          <a:chExt cx="0" cy="0"/>
+        </a:xfrm>
+      </p:grpSpPr>
+      <p:sp>
+        <p:nvSpPr>
+          <p:cNvPr id="2" name="Slide Image Placeholder 1"/>
+          <p:cNvSpPr>
+            <a:spLocks noGrp="1"/>
+          </p:cNvSpPr>
+          <p:nvPr>
+            <p:ph type="sldImg" idx="2"/>
+          </p:nvPr>
+        </p:nvSpPr>
+        <p:spPr/>
+      </p:sp>
+      <p:sp>
+        <p:nvSpPr>
+          <p:cNvPr id="3" name="Notes Placeholder 2"/>
+          <p:cNvSpPr>
+            <a:spLocks noGrp="1"/>
+          </p:cNvSpPr>
+          <p:nvPr>
+            <p:ph type="body" idx="3" sz="quarter"/>
+          </p:nvPr>
+        </p:nvSpPr>
+        <p:spPr/>
+        <p:txBody>
+          <a:bodyPr/>
+          <a:lstStyle/>
+          <a:p>
+            <a:r>
+              <a:t>Slow is the secret. Most lovemaking rushes to stimulation and a goal, but you can't build deep connection at full speed. Sacred union isn't performance or arriving anywhere, it's presence. Make love the way you'd meditate or pray: fully here, fully awake, in no hurry at all.</a:t>
+            </a:r>
+          </a:p>
+        </p:txBody>
+      </p:sp>
+      <p:sp>
+        <p:nvSpPr>
+          <p:cNvPr id="4" name="Slide Number Placeholder 3"/>
+          <p:cNvSpPr>
+            <a:spLocks noGrp="1"/>
+          </p:cNvSpPr>
+          <p:nvPr>
+            <p:ph type="sldNum" idx="5" sz="quarter"/>
+          </p:nvPr>
+        </p:nvSpPr>
+        <p:spPr/>
+      </p:sp>
+    </p:spTree>
+  </p:cSld>
+  <p:clrMapOvr>
+    <a:masterClrMapping/>
+  </p:clrMapOvr>
+</p:notes>
+</file>
+
+<file path=ppt/notesSlides/notesSlide25.xml><?xml version="1.0" encoding="utf-8"?>
+<p:notes xmlns:a="http://schemas.openxmlformats.org/drawingml/2006/main" xmlns:p="http://schemas.openxmlformats.org/presentationml/2006/main" xmlns:r="http://schemas.openxmlformats.org/officeDocument/2006/relationships">
+  <p:cSld>
+    <p:spTree>
+      <p:nvGrpSpPr>
+        <p:cNvPr id="1" name=""/>
+        <p:cNvGrpSpPr/>
+        <p:nvPr/>
+      </p:nvGrpSpPr>
+      <p:grpSpPr>
+        <a:xfrm>
+          <a:off x="0" y="0"/>
+          <a:ext cx="0" cy="0"/>
+          <a:chOff x="0" y="0"/>
+          <a:chExt cx="0" cy="0"/>
+        </a:xfrm>
+      </p:grpSpPr>
+      <p:sp>
+        <p:nvSpPr>
+          <p:cNvPr id="2" name="Slide Image Placeholder 1"/>
+          <p:cNvSpPr>
+            <a:spLocks noGrp="1"/>
+          </p:cNvSpPr>
+          <p:nvPr>
+            <p:ph type="sldImg" idx="2"/>
+          </p:nvPr>
+        </p:nvSpPr>
+        <p:spPr/>
+      </p:sp>
+      <p:sp>
+        <p:nvSpPr>
+          <p:cNvPr id="3" name="Notes Placeholder 2"/>
+          <p:cNvSpPr>
+            <a:spLocks noGrp="1"/>
+          </p:cNvSpPr>
+          <p:nvPr>
+            <p:ph type="body" idx="3" sz="quarter"/>
+          </p:nvPr>
+        </p:nvSpPr>
+        <p:spPr/>
+        <p:txBody>
+          <a:bodyPr/>
+          <a:lstStyle/>
+          <a:p>
+            <a:r>
+              <a:t>When you slow right down, something opens: space for feeling, space for vulnerability. And vulnerability is what lets two people actually meet, instead of two bodies going through the motions. Slowness turns sex into communion. Feeling is what makes it sacred.</a:t>
+            </a:r>
+          </a:p>
+        </p:txBody>
+      </p:sp>
+      <p:sp>
+        <p:nvSpPr>
+          <p:cNvPr id="4" name="Slide Number Placeholder 3"/>
+          <p:cNvSpPr>
+            <a:spLocks noGrp="1"/>
+          </p:cNvSpPr>
+          <p:nvPr>
+            <p:ph type="sldNum" idx="5" sz="quarter"/>
+          </p:nvPr>
+        </p:nvSpPr>
+        <p:spPr/>
+      </p:sp>
+    </p:spTree>
+  </p:cSld>
+  <p:clrMapOvr>
+    <a:masterClrMapping/>
+  </p:clrMapOvr>
+</p:notes>
+</file>
+
+<file path=ppt/notesSlides/notesSlide26.xml><?xml version="1.0" encoding="utf-8"?>
+<p:notes xmlns:a="http://schemas.openxmlformats.org/drawingml/2006/main" xmlns:p="http://schemas.openxmlformats.org/presentationml/2006/main" xmlns:r="http://schemas.openxmlformats.org/officeDocument/2006/relationships">
+  <p:cSld>
+    <p:spTree>
+      <p:nvGrpSpPr>
+        <p:cNvPr id="1" name=""/>
+        <p:cNvGrpSpPr/>
+        <p:nvPr/>
+      </p:nvGrpSpPr>
+      <p:grpSpPr>
+        <a:xfrm>
+          <a:off x="0" y="0"/>
+          <a:ext cx="0" cy="0"/>
+          <a:chOff x="0" y="0"/>
+          <a:chExt cx="0" cy="0"/>
+        </a:xfrm>
+      </p:grpSpPr>
+      <p:sp>
+        <p:nvSpPr>
+          <p:cNvPr id="2" name="Slide Image Placeholder 1"/>
+          <p:cNvSpPr>
+            <a:spLocks noGrp="1"/>
+          </p:cNvSpPr>
+          <p:nvPr>
+            <p:ph type="sldImg" idx="2"/>
+          </p:nvPr>
+        </p:nvSpPr>
+        <p:spPr/>
+      </p:sp>
+      <p:sp>
+        <p:nvSpPr>
+          <p:cNvPr id="3" name="Notes Placeholder 2"/>
+          <p:cNvSpPr>
+            <a:spLocks noGrp="1"/>
+          </p:cNvSpPr>
+          <p:nvPr>
+            <p:ph type="body" idx="3" sz="quarter"/>
+          </p:nvPr>
+        </p:nvSpPr>
+        <p:spPr/>
+        <p:txBody>
+          <a:bodyPr/>
+          <a:lstStyle/>
+          <a:p>
+            <a:r>
+              <a:t>Pose and let land before the practice and breakout: When do I feel truly safe and connected with another, and what creates it? What do I long for in intimacy that I've never said out loud? What helps me stay present instead of performing or disappearing?</a:t>
+            </a:r>
+          </a:p>
+        </p:txBody>
+      </p:sp>
+      <p:sp>
+        <p:nvSpPr>
+          <p:cNvPr id="4" name="Slide Number Placeholder 3"/>
+          <p:cNvSpPr>
+            <a:spLocks noGrp="1"/>
+          </p:cNvSpPr>
+          <p:nvPr>
+            <p:ph type="sldNum" idx="5" sz="quarter"/>
+          </p:nvPr>
+        </p:nvSpPr>
+        <p:spPr/>
+      </p:sp>
+    </p:spTree>
+  </p:cSld>
+  <p:clrMapOvr>
+    <a:masterClrMapping/>
+  </p:clrMapOvr>
+</p:notes>
+</file>
+
+<file path=ppt/notesSlides/notesSlide27.xml><?xml version="1.0" encoding="utf-8"?>
+<p:notes xmlns:a="http://schemas.openxmlformats.org/drawingml/2006/main" xmlns:p="http://schemas.openxmlformats.org/presentationml/2006/main" xmlns:r="http://schemas.openxmlformats.org/officeDocument/2006/relationships">
+  <p:cSld>
+    <p:spTree>
+      <p:nvGrpSpPr>
+        <p:cNvPr id="1" name=""/>
+        <p:cNvGrpSpPr/>
+        <p:nvPr/>
+      </p:nvGrpSpPr>
+      <p:grpSpPr>
+        <a:xfrm>
+          <a:off x="0" y="0"/>
+          <a:ext cx="0" cy="0"/>
+          <a:chOff x="0" y="0"/>
+          <a:chExt cx="0" cy="0"/>
+        </a:xfrm>
+      </p:grpSpPr>
+      <p:sp>
+        <p:nvSpPr>
+          <p:cNvPr id="2" name="Slide Image Placeholder 1"/>
+          <p:cNvSpPr>
+            <a:spLocks noGrp="1"/>
+          </p:cNvSpPr>
+          <p:nvPr>
+            <p:ph type="sldImg" idx="2"/>
+          </p:nvPr>
+        </p:nvSpPr>
+        <p:spPr/>
+      </p:sp>
+      <p:sp>
+        <p:nvSpPr>
+          <p:cNvPr id="3" name="Notes Placeholder 2"/>
+          <p:cNvSpPr>
+            <a:spLocks noGrp="1"/>
+          </p:cNvSpPr>
+          <p:nvPr>
+            <p:ph type="body" idx="3" sz="quarter"/>
+          </p:nvPr>
+        </p:nvSpPr>
+        <p:spPr/>
+        <p:txBody>
+          <a:bodyPr/>
+          <a:lstStyle/>
+          <a:p>
+            <a:r>
+              <a:t>Guide it. On Zoom they do it solo as rehearsal: hand on heart, or a soft gaze at their own eyes. 'Sit tall. Soften your gaze. Breathe slowly, in and out. Imagine sitting knee to knee with your beloved. You breathe together. You simply witness and are witnessed. No talking, no fixing, no performing. Notice the urge to look away or laugh, to break it. Stay anyway. Underneath the awkwardness there's a person who can be truly seen. Tonight, practise letting yourself be seen, starting with yourself.'</a:t>
+            </a:r>
+          </a:p>
+        </p:txBody>
+      </p:sp>
+      <p:sp>
+        <p:nvSpPr>
+          <p:cNvPr id="4" name="Slide Number Placeholder 3"/>
+          <p:cNvSpPr>
+            <a:spLocks noGrp="1"/>
+          </p:cNvSpPr>
+          <p:nvPr>
+            <p:ph type="sldNum" idx="5" sz="quarter"/>
+          </p:nvPr>
+        </p:nvSpPr>
+        <p:spPr/>
+      </p:sp>
+    </p:spTree>
+  </p:cSld>
+  <p:clrMapOvr>
+    <a:masterClrMapping/>
+  </p:clrMapOvr>
+</p:notes>
+</file>
+
+<file path=ppt/notesSlides/notesSlide28.xml><?xml version="1.0" encoding="utf-8"?>
+<p:notes xmlns:a="http://schemas.openxmlformats.org/drawingml/2006/main" xmlns:p="http://schemas.openxmlformats.org/presentationml/2006/main" xmlns:r="http://schemas.openxmlformats.org/officeDocument/2006/relationships">
+  <p:cSld>
+    <p:spTree>
+      <p:nvGrpSpPr>
+        <p:cNvPr id="1" name=""/>
+        <p:cNvGrpSpPr/>
+        <p:nvPr/>
+      </p:nvGrpSpPr>
+      <p:grpSpPr>
+        <a:xfrm>
+          <a:off x="0" y="0"/>
+          <a:ext cx="0" cy="0"/>
+          <a:chOff x="0" y="0"/>
+          <a:chExt cx="0" cy="0"/>
+        </a:xfrm>
+      </p:grpSpPr>
+      <p:sp>
+        <p:nvSpPr>
+          <p:cNvPr id="2" name="Slide Image Placeholder 1"/>
+          <p:cNvSpPr>
+            <a:spLocks noGrp="1"/>
+          </p:cNvSpPr>
+          <p:nvPr>
+            <p:ph type="sldImg" idx="2"/>
+          </p:nvPr>
+        </p:nvSpPr>
+        <p:spPr/>
+      </p:sp>
+      <p:sp>
+        <p:nvSpPr>
+          <p:cNvPr id="3" name="Notes Placeholder 2"/>
+          <p:cNvSpPr>
+            <a:spLocks noGrp="1"/>
+          </p:cNvSpPr>
+          <p:nvPr>
+            <p:ph type="body" idx="3" sz="quarter"/>
+          </p:nvPr>
+        </p:nvSpPr>
+        <p:spPr/>
+        <p:txBody>
+          <a:bodyPr/>
+          <a:lstStyle/>
+          <a:p>
+            <a:r>
+              <a:t>Broadcast. In pairs, Partner A about 6 minutes: 'I feel most safe and connected with someone when...' / 'What pulls me out of presence in intimacy is...' / 'What helps me come back is...' Partner B witnesses. Swap. Main-room: one thing that helps you feel safe and connected.</a:t>
+            </a:r>
+          </a:p>
+        </p:txBody>
+      </p:sp>
+      <p:sp>
+        <p:nvSpPr>
+          <p:cNvPr id="4" name="Slide Number Placeholder 3"/>
+          <p:cNvSpPr>
+            <a:spLocks noGrp="1"/>
+          </p:cNvSpPr>
+          <p:nvPr>
+            <p:ph type="sldNum" idx="5" sz="quarter"/>
+          </p:nvPr>
+        </p:nvSpPr>
+        <p:spPr/>
+      </p:sp>
+    </p:spTree>
+  </p:cSld>
+  <p:clrMapOvr>
+    <a:masterClrMapping/>
+  </p:clrMapOvr>
+</p:notes>
+</file>
+
+<file path=ppt/notesSlides/notesSlide29.xml><?xml version="1.0" encoding="utf-8"?>
+<p:notes xmlns:a="http://schemas.openxmlformats.org/drawingml/2006/main" xmlns:p="http://schemas.openxmlformats.org/presentationml/2006/main" xmlns:r="http://schemas.openxmlformats.org/officeDocument/2006/relationships">
+  <p:cSld>
+    <p:spTree>
+      <p:nvGrpSpPr>
+        <p:cNvPr id="1" name=""/>
+        <p:cNvGrpSpPr/>
+        <p:nvPr/>
+      </p:nvGrpSpPr>
+      <p:grpSpPr>
+        <a:xfrm>
+          <a:off x="0" y="0"/>
+          <a:ext cx="0" cy="0"/>
+          <a:chOff x="0" y="0"/>
+          <a:chExt cx="0" cy="0"/>
+        </a:xfrm>
+      </p:grpSpPr>
+      <p:sp>
+        <p:nvSpPr>
+          <p:cNvPr id="2" name="Slide Image Placeholder 1"/>
+          <p:cNvSpPr>
+            <a:spLocks noGrp="1"/>
+          </p:cNvSpPr>
+          <p:nvPr>
+            <p:ph type="sldImg" idx="2"/>
+          </p:nvPr>
+        </p:nvSpPr>
+        <p:spPr/>
+      </p:sp>
+      <p:sp>
+        <p:nvSpPr>
+          <p:cNvPr id="3" name="Notes Placeholder 2"/>
+          <p:cNvSpPr>
+            <a:spLocks noGrp="1"/>
+          </p:cNvSpPr>
+          <p:nvPr>
+            <p:ph type="body" idx="3" sz="quarter"/>
+          </p:nvPr>
+        </p:nvSpPr>
+        <p:spPr/>
+        <p:txBody>
+          <a:bodyPr/>
+          <a:lstStyle/>
+          <a:p>
+            <a:r>
+              <a:t>Lovemaking can be a ritual, and it starts before you ever touch. Create a special space: candles, soft music, fabrics that feel beautiful, a door that closes. You're telling your nervous system, and your beloved: this is sacred time.</a:t>
+            </a:r>
+          </a:p>
+        </p:txBody>
+      </p:sp>
+      <p:sp>
+        <p:nvSpPr>
+          <p:cNvPr id="4" name="Slide Number Placeholder 3"/>
+          <p:cNvSpPr>
+            <a:spLocks noGrp="1"/>
+          </p:cNvSpPr>
+          <p:nvPr>
+            <p:ph type="sldNum" idx="5" sz="quarter"/>
+          </p:nvPr>
+        </p:nvSpPr>
+        <p:spPr/>
+      </p:sp>
+    </p:spTree>
+  </p:cSld>
+  <p:clrMapOvr>
+    <a:masterClrMapping/>
+  </p:clrMapOvr>
+</p:notes>
+</file>
+
+<file path=ppt/notesSlides/notesSlide3.xml><?xml version="1.0" encoding="utf-8"?>
+<p:notes xmlns:a="http://schemas.openxmlformats.org/drawingml/2006/main" xmlns:p="http://schemas.openxmlformats.org/presentationml/2006/main" xmlns:r="http://schemas.openxmlformats.org/officeDocument/2006/relationships">
+  <p:cSld>
+    <p:spTree>
+      <p:nvGrpSpPr>
+        <p:cNvPr id="1" name=""/>
+        <p:cNvGrpSpPr/>
+        <p:nvPr/>
+      </p:nvGrpSpPr>
+      <p:grpSpPr>
+        <a:xfrm>
+          <a:off x="0" y="0"/>
+          <a:ext cx="0" cy="0"/>
+          <a:chOff x="0" y="0"/>
+          <a:chExt cx="0" cy="0"/>
+        </a:xfrm>
+      </p:grpSpPr>
+      <p:sp>
+        <p:nvSpPr>
+          <p:cNvPr id="2" name="Slide Image Placeholder 1"/>
+          <p:cNvSpPr>
+            <a:spLocks noGrp="1"/>
+          </p:cNvSpPr>
+          <p:nvPr>
+            <p:ph type="sldImg" idx="2"/>
+          </p:nvPr>
+        </p:nvSpPr>
+        <p:spPr/>
+      </p:sp>
+      <p:sp>
+        <p:nvSpPr>
+          <p:cNvPr id="3" name="Notes Placeholder 2"/>
+          <p:cNvSpPr>
+            <a:spLocks noGrp="1"/>
+          </p:cNvSpPr>
+          <p:nvPr>
+            <p:ph type="body" idx="3" sz="quarter"/>
+          </p:nvPr>
+        </p:nvSpPr>
+        <p:spPr/>
+        <p:txBody>
+          <a:bodyPr/>
+          <a:lstStyle/>
+          <a:p>
+            <a:r>
+              <a:t>Guide the practice slowly, hands on heart: 'Both hands on your heart. Feel the warmth. Ask yourself, the way you'd ask your dearest friend: How are you, really? What's going on for you? Listen. Then say: I hear you. I'm here. If something tender rises: I see this, and I'm not going anywhere. Nothing to fix. Nothing to perform. Just meeting yourself with kindness.' Sit in it two to three minutes. This is the ground everything stands on.</a:t>
+            </a:r>
+          </a:p>
+        </p:txBody>
+      </p:sp>
+      <p:sp>
+        <p:nvSpPr>
+          <p:cNvPr id="4" name="Slide Number Placeholder 3"/>
+          <p:cNvSpPr>
+            <a:spLocks noGrp="1"/>
+          </p:cNvSpPr>
+          <p:nvPr>
+            <p:ph type="sldNum" idx="5" sz="quarter"/>
+          </p:nvPr>
+        </p:nvSpPr>
+        <p:spPr/>
+      </p:sp>
+    </p:spTree>
+  </p:cSld>
+  <p:clrMapOvr>
+    <a:masterClrMapping/>
+  </p:clrMapOvr>
+</p:notes>
+</file>
+
+<file path=ppt/notesSlides/notesSlide30.xml><?xml version="1.0" encoding="utf-8"?>
+<p:notes xmlns:a="http://schemas.openxmlformats.org/drawingml/2006/main" xmlns:p="http://schemas.openxmlformats.org/presentationml/2006/main" xmlns:r="http://schemas.openxmlformats.org/officeDocument/2006/relationships">
+  <p:cSld>
+    <p:spTree>
+      <p:nvGrpSpPr>
+        <p:cNvPr id="1" name=""/>
+        <p:cNvGrpSpPr/>
+        <p:nvPr/>
+      </p:nvGrpSpPr>
+      <p:grpSpPr>
+        <a:xfrm>
+          <a:off x="0" y="0"/>
+          <a:ext cx="0" cy="0"/>
+          <a:chOff x="0" y="0"/>
+          <a:chExt cx="0" cy="0"/>
+        </a:xfrm>
+      </p:grpSpPr>
+      <p:sp>
+        <p:nvSpPr>
+          <p:cNvPr id="2" name="Slide Image Placeholder 1"/>
+          <p:cNvSpPr>
+            <a:spLocks noGrp="1"/>
+          </p:cNvSpPr>
+          <p:nvPr>
+            <p:ph type="sldImg" idx="2"/>
+          </p:nvPr>
+        </p:nvSpPr>
+        <p:spPr/>
+      </p:sp>
+      <p:sp>
+        <p:nvSpPr>
+          <p:cNvPr id="3" name="Notes Placeholder 2"/>
+          <p:cNvSpPr>
+            <a:spLocks noGrp="1"/>
+          </p:cNvSpPr>
+          <p:nvPr>
+            <p:ph type="body" idx="3" sz="quarter"/>
+          </p:nvPr>
+        </p:nvSpPr>
+        <p:spPr/>
+        <p:txBody>
+          <a:bodyPr/>
+          <a:lstStyle/>
+          <a:p>
+            <a:r>
+              <a:t>The dance of love, and it's slow. Breathe together first. Eye gaze. See each other's beauty, power and vulnerability. Then touch, slowly, feather the whole body, fingertips sending love, no destination. Take turns giving and receiving. Frame it as presence, not technique: the point isn't what you do, it's how present you are while you do it.</a:t>
+            </a:r>
+          </a:p>
+        </p:txBody>
+      </p:sp>
+      <p:sp>
+        <p:nvSpPr>
+          <p:cNvPr id="4" name="Slide Number Placeholder 3"/>
+          <p:cNvSpPr>
+            <a:spLocks noGrp="1"/>
+          </p:cNvSpPr>
+          <p:nvPr>
+            <p:ph type="sldNum" idx="5" sz="quarter"/>
+          </p:nvPr>
+        </p:nvSpPr>
+        <p:spPr/>
+      </p:sp>
+    </p:spTree>
+  </p:cSld>
+  <p:clrMapOvr>
+    <a:masterClrMapping/>
+  </p:clrMapOvr>
+</p:notes>
+</file>
+
+<file path=ppt/notesSlides/notesSlide31.xml><?xml version="1.0" encoding="utf-8"?>
+<p:notes xmlns:a="http://schemas.openxmlformats.org/drawingml/2006/main" xmlns:p="http://schemas.openxmlformats.org/presentationml/2006/main" xmlns:r="http://schemas.openxmlformats.org/officeDocument/2006/relationships">
+  <p:cSld>
+    <p:spTree>
+      <p:nvGrpSpPr>
+        <p:cNvPr id="1" name=""/>
+        <p:cNvGrpSpPr/>
+        <p:nvPr/>
+      </p:nvGrpSpPr>
+      <p:grpSpPr>
+        <a:xfrm>
+          <a:off x="0" y="0"/>
+          <a:ext cx="0" cy="0"/>
+          <a:chOff x="0" y="0"/>
+          <a:chExt cx="0" cy="0"/>
+        </a:xfrm>
+      </p:grpSpPr>
+      <p:sp>
+        <p:nvSpPr>
+          <p:cNvPr id="2" name="Slide Image Placeholder 1"/>
+          <p:cNvSpPr>
+            <a:spLocks noGrp="1"/>
+          </p:cNvSpPr>
+          <p:nvPr>
+            <p:ph type="sldImg" idx="2"/>
+          </p:nvPr>
+        </p:nvSpPr>
+        <p:spPr/>
+      </p:sp>
+      <p:sp>
+        <p:nvSpPr>
+          <p:cNvPr id="3" name="Notes Placeholder 2"/>
+          <p:cNvSpPr>
+            <a:spLocks noGrp="1"/>
+          </p:cNvSpPr>
+          <p:nvPr>
+            <p:ph type="body" idx="3" sz="quarter"/>
+          </p:nvPr>
+        </p:nvSpPr>
+        <p:spPr/>
+        <p:txBody>
+          <a:bodyPr/>
+          <a:lstStyle/>
+          <a:p>
+            <a:r>
+              <a:t>Pose first: what do I desire that I've been too afraid to ask for, and what would it feel like to simply receive? Broadcast. In pairs, Partner A about 6 minutes, practising two things out loud: speak a desire cleanly and warmly, 'Something I long for in intimacy is...' (a desire, not a complaint); then practise receiving, let Partner B offer a genuine appreciation and simply say 'thank you,' let it land, notice the urge to deflect. Partner B witnesses and offers the appreciation. Swap. Main-room: what was harder, speaking your desire or receiving?</a:t>
+            </a:r>
+          </a:p>
+        </p:txBody>
+      </p:sp>
+      <p:sp>
+        <p:nvSpPr>
+          <p:cNvPr id="4" name="Slide Number Placeholder 3"/>
+          <p:cNvSpPr>
+            <a:spLocks noGrp="1"/>
+          </p:cNvSpPr>
+          <p:nvPr>
+            <p:ph type="sldNum" idx="5" sz="quarter"/>
+          </p:nvPr>
+        </p:nvSpPr>
+        <p:spPr/>
+      </p:sp>
+    </p:spTree>
+  </p:cSld>
+  <p:clrMapOvr>
+    <a:masterClrMapping/>
+  </p:clrMapOvr>
+</p:notes>
+</file>
+
+<file path=ppt/notesSlides/notesSlide32.xml><?xml version="1.0" encoding="utf-8"?>
+<p:notes xmlns:a="http://schemas.openxmlformats.org/drawingml/2006/main" xmlns:p="http://schemas.openxmlformats.org/presentationml/2006/main" xmlns:r="http://schemas.openxmlformats.org/officeDocument/2006/relationships">
+  <p:cSld>
+    <p:spTree>
+      <p:nvGrpSpPr>
+        <p:cNvPr id="1" name=""/>
+        <p:cNvGrpSpPr/>
+        <p:nvPr/>
+      </p:nvGrpSpPr>
+      <p:grpSpPr>
+        <a:xfrm>
+          <a:off x="0" y="0"/>
+          <a:ext cx="0" cy="0"/>
+          <a:chOff x="0" y="0"/>
+          <a:chExt cx="0" cy="0"/>
+        </a:xfrm>
+      </p:grpSpPr>
+      <p:sp>
+        <p:nvSpPr>
+          <p:cNvPr id="2" name="Slide Image Placeholder 1"/>
+          <p:cNvSpPr>
+            <a:spLocks noGrp="1"/>
+          </p:cNvSpPr>
+          <p:nvPr>
+            <p:ph type="sldImg" idx="2"/>
+          </p:nvPr>
+        </p:nvSpPr>
+        <p:spPr/>
+      </p:sp>
+      <p:sp>
+        <p:nvSpPr>
+          <p:cNvPr id="3" name="Notes Placeholder 2"/>
+          <p:cNvSpPr>
+            <a:spLocks noGrp="1"/>
+          </p:cNvSpPr>
+          <p:nvPr>
+            <p:ph type="body" idx="3" sz="quarter"/>
+          </p:nvPr>
+        </p:nvSpPr>
+        <p:spPr/>
+        <p:txBody>
+          <a:bodyPr/>
+          <a:lstStyle/>
+          <a:p>
+            <a:r>
+              <a:t>Take-home, solo or with a chosen partner: create one pocket of sacred time. Light a candle. Sit knee to knee, or hand on heart if solo. Breathe together a few minutes. Eye gaze for three. Then slow, reverent touch or self-touch, no goal at all, just presence and love. Notice how different it feels when you're fully here.</a:t>
+            </a:r>
+          </a:p>
+        </p:txBody>
+      </p:sp>
+      <p:sp>
+        <p:nvSpPr>
+          <p:cNvPr id="4" name="Slide Number Placeholder 3"/>
+          <p:cNvSpPr>
+            <a:spLocks noGrp="1"/>
+          </p:cNvSpPr>
+          <p:nvPr>
+            <p:ph type="sldNum" idx="5" sz="quarter"/>
+          </p:nvPr>
+        </p:nvSpPr>
+        <p:spPr/>
+      </p:sp>
+    </p:spTree>
+  </p:cSld>
+  <p:clrMapOvr>
+    <a:masterClrMapping/>
+  </p:clrMapOvr>
+</p:notes>
+</file>
+
+<file path=ppt/notesSlides/notesSlide33.xml><?xml version="1.0" encoding="utf-8"?>
+<p:notes xmlns:a="http://schemas.openxmlformats.org/drawingml/2006/main" xmlns:p="http://schemas.openxmlformats.org/presentationml/2006/main" xmlns:r="http://schemas.openxmlformats.org/officeDocument/2006/relationships">
+  <p:cSld>
+    <p:spTree>
+      <p:nvGrpSpPr>
+        <p:cNvPr id="1" name=""/>
+        <p:cNvGrpSpPr/>
+        <p:nvPr/>
+      </p:nvGrpSpPr>
+      <p:grpSpPr>
+        <a:xfrm>
+          <a:off x="0" y="0"/>
+          <a:ext cx="0" cy="0"/>
+          <a:chOff x="0" y="0"/>
+          <a:chExt cx="0" cy="0"/>
+        </a:xfrm>
+      </p:grpSpPr>
+      <p:sp>
+        <p:nvSpPr>
+          <p:cNvPr id="2" name="Slide Image Placeholder 1"/>
+          <p:cNvSpPr>
+            <a:spLocks noGrp="1"/>
+          </p:cNvSpPr>
+          <p:nvPr>
+            <p:ph type="sldImg" idx="2"/>
+          </p:nvPr>
+        </p:nvSpPr>
+        <p:spPr/>
+      </p:sp>
+      <p:sp>
+        <p:nvSpPr>
+          <p:cNvPr id="3" name="Notes Placeholder 2"/>
+          <p:cNvSpPr>
+            <a:spLocks noGrp="1"/>
+          </p:cNvSpPr>
+          <p:nvPr>
+            <p:ph type="body" idx="3" sz="quarter"/>
+          </p:nvPr>
+        </p:nvSpPr>
+        <p:spPr/>
+        <p:txBody>
+          <a:bodyPr/>
+          <a:lstStyle/>
+          <a:p>
+            <a:r>
+              <a:t>Close the circle. Claiming round, one line each: 'The reverence I'm bringing to intimacy is...' The circle answers together, warm: 'Sacred.' Remind them: your body, your pleasure, your desire, all holy. Blow out the candle together.</a:t>
+            </a:r>
+          </a:p>
+        </p:txBody>
+      </p:sp>
+      <p:sp>
+        <p:nvSpPr>
+          <p:cNvPr id="4" name="Slide Number Placeholder 3"/>
+          <p:cNvSpPr>
+            <a:spLocks noGrp="1"/>
+          </p:cNvSpPr>
+          <p:nvPr>
+            <p:ph type="sldNum" idx="5" sz="quarter"/>
+          </p:nvPr>
+        </p:nvSpPr>
+        <p:spPr/>
+      </p:sp>
+    </p:spTree>
+  </p:cSld>
+  <p:clrMapOvr>
+    <a:masterClrMapping/>
+  </p:clrMapOvr>
+</p:notes>
+</file>
+
+<file path=ppt/notesSlides/notesSlide4.xml><?xml version="1.0" encoding="utf-8"?>
+<p:notes xmlns:a="http://schemas.openxmlformats.org/drawingml/2006/main" xmlns:p="http://schemas.openxmlformats.org/presentationml/2006/main" xmlns:r="http://schemas.openxmlformats.org/officeDocument/2006/relationships">
+  <p:cSld>
+    <p:spTree>
+      <p:nvGrpSpPr>
+        <p:cNvPr id="1" name=""/>
+        <p:cNvGrpSpPr/>
+        <p:nvPr/>
+      </p:nvGrpSpPr>
+      <p:grpSpPr>
+        <a:xfrm>
+          <a:off x="0" y="0"/>
+          <a:ext cx="0" cy="0"/>
+          <a:chOff x="0" y="0"/>
+          <a:chExt cx="0" cy="0"/>
+        </a:xfrm>
+      </p:grpSpPr>
+      <p:sp>
+        <p:nvSpPr>
+          <p:cNvPr id="2" name="Slide Image Placeholder 1"/>
+          <p:cNvSpPr>
+            <a:spLocks noGrp="1"/>
+          </p:cNvSpPr>
+          <p:nvPr>
+            <p:ph type="sldImg" idx="2"/>
+          </p:nvPr>
+        </p:nvSpPr>
+        <p:spPr/>
+      </p:sp>
+      <p:sp>
+        <p:nvSpPr>
+          <p:cNvPr id="3" name="Notes Placeholder 2"/>
+          <p:cNvSpPr>
+            <a:spLocks noGrp="1"/>
+          </p:cNvSpPr>
+          <p:nvPr>
+            <p:ph type="body" idx="3" sz="quarter"/>
+          </p:nvPr>
+        </p:nvSpPr>
+        <p:spPr/>
+        <p:txBody>
+          <a:bodyPr/>
+          <a:lstStyle/>
+          <a:p>
+            <a:r>
+              <a:t>Teach the two steps, in order. Step one is awareness: noticing the moment you close down, contract, go reactive, the old story that says 'not enough.' Step two is self-love. But awareness alone can curdle into self-criticism, 'I can feel it and I still do it, what's wrong with me?' So the key of step two: you don't need to fix yourself. You are not a problem to be solved.</a:t>
+            </a:r>
+          </a:p>
+        </p:txBody>
+      </p:sp>
+      <p:sp>
+        <p:nvSpPr>
+          <p:cNvPr id="4" name="Slide Number Placeholder 3"/>
+          <p:cNvSpPr>
+            <a:spLocks noGrp="1"/>
+          </p:cNvSpPr>
+          <p:nvPr>
+            <p:ph type="sldNum" idx="5" sz="quarter"/>
+          </p:nvPr>
+        </p:nvSpPr>
+        <p:spPr/>
+      </p:sp>
+    </p:spTree>
+  </p:cSld>
+  <p:clrMapOvr>
+    <a:masterClrMapping/>
+  </p:clrMapOvr>
+</p:notes>
+</file>
+
+<file path=ppt/notesSlides/notesSlide5.xml><?xml version="1.0" encoding="utf-8"?>
+<p:notes xmlns:a="http://schemas.openxmlformats.org/drawingml/2006/main" xmlns:p="http://schemas.openxmlformats.org/presentationml/2006/main" xmlns:r="http://schemas.openxmlformats.org/officeDocument/2006/relationships">
+  <p:cSld>
+    <p:spTree>
+      <p:nvGrpSpPr>
+        <p:cNvPr id="1" name=""/>
+        <p:cNvGrpSpPr/>
+        <p:nvPr/>
+      </p:nvGrpSpPr>
+      <p:grpSpPr>
+        <a:xfrm>
+          <a:off x="0" y="0"/>
+          <a:ext cx="0" cy="0"/>
+          <a:chOff x="0" y="0"/>
+          <a:chExt cx="0" cy="0"/>
+        </a:xfrm>
+      </p:grpSpPr>
+      <p:sp>
+        <p:nvSpPr>
+          <p:cNvPr id="2" name="Slide Image Placeholder 1"/>
+          <p:cNvSpPr>
+            <a:spLocks noGrp="1"/>
+          </p:cNvSpPr>
+          <p:nvPr>
+            <p:ph type="sldImg" idx="2"/>
+          </p:nvPr>
+        </p:nvSpPr>
+        <p:spPr/>
+      </p:sp>
+      <p:sp>
+        <p:nvSpPr>
+          <p:cNvPr id="3" name="Notes Placeholder 2"/>
+          <p:cNvSpPr>
+            <a:spLocks noGrp="1"/>
+          </p:cNvSpPr>
+          <p:nvPr>
+            <p:ph type="body" idx="3" sz="quarter"/>
+          </p:nvPr>
+        </p:nvSpPr>
+        <p:spPr/>
+        <p:txBody>
+          <a:bodyPr/>
+          <a:lstStyle/>
+          <a:p>
+            <a:r>
+              <a:t>Let this land. You can feel yourself contracting, closing, bracing, and you don't have to make it go away. Nothing about you needs solving tonight.</a:t>
+            </a:r>
+          </a:p>
+        </p:txBody>
+      </p:sp>
+      <p:sp>
+        <p:nvSpPr>
+          <p:cNvPr id="4" name="Slide Number Placeholder 3"/>
+          <p:cNvSpPr>
+            <a:spLocks noGrp="1"/>
+          </p:cNvSpPr>
+          <p:nvPr>
+            <p:ph type="sldNum" idx="5" sz="quarter"/>
+          </p:nvPr>
+        </p:nvSpPr>
+        <p:spPr/>
+      </p:sp>
+    </p:spTree>
+  </p:cSld>
+  <p:clrMapOvr>
+    <a:masterClrMapping/>
+  </p:clrMapOvr>
+</p:notes>
+</file>
+
+<file path=ppt/notesSlides/notesSlide6.xml><?xml version="1.0" encoding="utf-8"?>
+<p:notes xmlns:a="http://schemas.openxmlformats.org/drawingml/2006/main" xmlns:p="http://schemas.openxmlformats.org/presentationml/2006/main" xmlns:r="http://schemas.openxmlformats.org/officeDocument/2006/relationships">
+  <p:cSld>
+    <p:spTree>
+      <p:nvGrpSpPr>
+        <p:cNvPr id="1" name=""/>
+        <p:cNvGrpSpPr/>
+        <p:nvPr/>
+      </p:nvGrpSpPr>
+      <p:grpSpPr>
+        <a:xfrm>
+          <a:off x="0" y="0"/>
+          <a:ext cx="0" cy="0"/>
+          <a:chOff x="0" y="0"/>
+          <a:chExt cx="0" cy="0"/>
+        </a:xfrm>
+      </p:grpSpPr>
+      <p:sp>
+        <p:nvSpPr>
+          <p:cNvPr id="2" name="Slide Image Placeholder 1"/>
+          <p:cNvSpPr>
+            <a:spLocks noGrp="1"/>
+          </p:cNvSpPr>
+          <p:nvPr>
+            <p:ph type="sldImg" idx="2"/>
+          </p:nvPr>
+        </p:nvSpPr>
+        <p:spPr/>
+      </p:sp>
+      <p:sp>
+        <p:nvSpPr>
+          <p:cNvPr id="3" name="Notes Placeholder 2"/>
+          <p:cNvSpPr>
+            <a:spLocks noGrp="1"/>
+          </p:cNvSpPr>
+          <p:nvPr>
+            <p:ph type="body" idx="3" sz="quarter"/>
+          </p:nvPr>
+        </p:nvSpPr>
+        <p:spPr/>
+        <p:txBody>
+          <a:bodyPr/>
+          <a:lstStyle/>
+          <a:p>
+            <a:r>
+              <a:t>This is the heart of it. The practice is not getting rid of the contraction. The practice is opening to something bigger than you, irrespective of the contraction. You feel yourself close, and you open anyway, not by forcing yourself open, and not by fixing the closing first, but by turning toward something larger while the contraction is still here: love, life, breath, the sacred. Over time the contraction stops running the show, not because you defeated it, but because you stopped making it the centre.</a:t>
+            </a:r>
+          </a:p>
+        </p:txBody>
+      </p:sp>
+      <p:sp>
+        <p:nvSpPr>
+          <p:cNvPr id="4" name="Slide Number Placeholder 3"/>
+          <p:cNvSpPr>
+            <a:spLocks noGrp="1"/>
+          </p:cNvSpPr>
+          <p:nvPr>
+            <p:ph type="sldNum" idx="5" sz="quarter"/>
+          </p:nvPr>
+        </p:nvSpPr>
+        <p:spPr/>
+      </p:sp>
+    </p:spTree>
+  </p:cSld>
+  <p:clrMapOvr>
+    <a:masterClrMapping/>
+  </p:clrMapOvr>
+</p:notes>
+</file>
+
+<file path=ppt/notesSlides/notesSlide7.xml><?xml version="1.0" encoding="utf-8"?>
+<p:notes xmlns:a="http://schemas.openxmlformats.org/drawingml/2006/main" xmlns:p="http://schemas.openxmlformats.org/presentationml/2006/main" xmlns:r="http://schemas.openxmlformats.org/officeDocument/2006/relationships">
+  <p:cSld>
+    <p:spTree>
+      <p:nvGrpSpPr>
+        <p:cNvPr id="1" name=""/>
+        <p:cNvGrpSpPr/>
+        <p:nvPr/>
+      </p:nvGrpSpPr>
+      <p:grpSpPr>
+        <a:xfrm>
+          <a:off x="0" y="0"/>
+          <a:ext cx="0" cy="0"/>
+          <a:chOff x="0" y="0"/>
+          <a:chExt cx="0" cy="0"/>
+        </a:xfrm>
+      </p:grpSpPr>
+      <p:sp>
+        <p:nvSpPr>
+          <p:cNvPr id="2" name="Slide Image Placeholder 1"/>
+          <p:cNvSpPr>
+            <a:spLocks noGrp="1"/>
+          </p:cNvSpPr>
+          <p:nvPr>
+            <p:ph type="sldImg" idx="2"/>
+          </p:nvPr>
+        </p:nvSpPr>
+        <p:spPr/>
+      </p:sp>
+      <p:sp>
+        <p:nvSpPr>
+          <p:cNvPr id="3" name="Notes Placeholder 2"/>
+          <p:cNvSpPr>
+            <a:spLocks noGrp="1"/>
+          </p:cNvSpPr>
+          <p:nvPr>
+            <p:ph type="body" idx="3" sz="quarter"/>
+          </p:nvPr>
+        </p:nvSpPr>
+        <p:spPr/>
+        <p:txBody>
+          <a:bodyPr/>
+          <a:lstStyle/>
+          <a:p>
+            <a:r>
+              <a:t>Name the trap. Spirituality is not bypassing. Bypassing uses 'love and light' to rise above your humanness and pretend the hurt or fear isn't there, which buries it. Real practice does the opposite: it lets the contracted, scared, reactive parts stay exactly as they are, and opens to something bigger while holding them with love. Those parts are usually young and protective. You don't shame them, and you don't fix them. You let them be held.</a:t>
+            </a:r>
+          </a:p>
+        </p:txBody>
+      </p:sp>
+      <p:sp>
+        <p:nvSpPr>
+          <p:cNvPr id="4" name="Slide Number Placeholder 3"/>
+          <p:cNvSpPr>
+            <a:spLocks noGrp="1"/>
+          </p:cNvSpPr>
+          <p:nvPr>
+            <p:ph type="sldNum" idx="5" sz="quarter"/>
+          </p:nvPr>
+        </p:nvSpPr>
+        <p:spPr/>
+      </p:sp>
+    </p:spTree>
+  </p:cSld>
+  <p:clrMapOvr>
+    <a:masterClrMapping/>
+  </p:clrMapOvr>
+</p:notes>
+</file>
+
+<file path=ppt/notesSlides/notesSlide8.xml><?xml version="1.0" encoding="utf-8"?>
+<p:notes xmlns:a="http://schemas.openxmlformats.org/drawingml/2006/main" xmlns:p="http://schemas.openxmlformats.org/presentationml/2006/main" xmlns:r="http://schemas.openxmlformats.org/officeDocument/2006/relationships">
+  <p:cSld>
+    <p:spTree>
+      <p:nvGrpSpPr>
+        <p:cNvPr id="1" name=""/>
+        <p:cNvGrpSpPr/>
+        <p:nvPr/>
+      </p:nvGrpSpPr>
+      <p:grpSpPr>
+        <a:xfrm>
+          <a:off x="0" y="0"/>
+          <a:ext cx="0" cy="0"/>
+          <a:chOff x="0" y="0"/>
+          <a:chExt cx="0" cy="0"/>
+        </a:xfrm>
+      </p:grpSpPr>
+      <p:sp>
+        <p:nvSpPr>
+          <p:cNvPr id="2" name="Slide Image Placeholder 1"/>
+          <p:cNvSpPr>
+            <a:spLocks noGrp="1"/>
+          </p:cNvSpPr>
+          <p:nvPr>
+            <p:ph type="sldImg" idx="2"/>
+          </p:nvPr>
+        </p:nvSpPr>
+        <p:spPr/>
+      </p:sp>
+      <p:sp>
+        <p:nvSpPr>
+          <p:cNvPr id="3" name="Notes Placeholder 2"/>
+          <p:cNvSpPr>
+            <a:spLocks noGrp="1"/>
+          </p:cNvSpPr>
+          <p:nvPr>
+            <p:ph type="body" idx="3" sz="quarter"/>
+          </p:nvPr>
+        </p:nvSpPr>
+        <p:spPr/>
+        <p:txBody>
+          <a:bodyPr/>
+          <a:lstStyle/>
+          <a:p>
+            <a:r>
+              <a:t>Teach the Blueprint. Your body is always guiding you: it speaks in contraction and opening, yes and no, turn-on and turn-off. That is your Blueprint, your inner guidance system. Most of us were taught to override it and not trust it. Coming home to your body means learning to read and trust those signals again. So when you feel yourself close, that's not a fault, it's information from your guidance system.</a:t>
+            </a:r>
+          </a:p>
+        </p:txBody>
+      </p:sp>
+      <p:sp>
+        <p:nvSpPr>
+          <p:cNvPr id="4" name="Slide Number Placeholder 3"/>
+          <p:cNvSpPr>
+            <a:spLocks noGrp="1"/>
+          </p:cNvSpPr>
+          <p:nvPr>
+            <p:ph type="sldNum" idx="5" sz="quarter"/>
+          </p:nvPr>
+        </p:nvSpPr>
+        <p:spPr/>
+      </p:sp>
+    </p:spTree>
+  </p:cSld>
+  <p:clrMapOvr>
+    <a:masterClrMapping/>
+  </p:clrMapOvr>
+</p:notes>
+</file>
+
+<file path=ppt/notesSlides/notesSlide9.xml><?xml version="1.0" encoding="utf-8"?>
+<p:notes xmlns:a="http://schemas.openxmlformats.org/drawingml/2006/main" xmlns:p="http://schemas.openxmlformats.org/presentationml/2006/main" xmlns:r="http://schemas.openxmlformats.org/officeDocument/2006/relationships">
+  <p:cSld>
+    <p:spTree>
+      <p:nvGrpSpPr>
+        <p:cNvPr id="1" name=""/>
+        <p:cNvGrpSpPr/>
+        <p:nvPr/>
+      </p:nvGrpSpPr>
+      <p:grpSpPr>
+        <a:xfrm>
+          <a:off x="0" y="0"/>
+          <a:ext cx="0" cy="0"/>
+          <a:chOff x="0" y="0"/>
+          <a:chExt cx="0" cy="0"/>
+        </a:xfrm>
+      </p:grpSpPr>
+      <p:sp>
+        <p:nvSpPr>
+          <p:cNvPr id="2" name="Slide Image Placeholder 1"/>
+          <p:cNvSpPr>
+            <a:spLocks noGrp="1"/>
+          </p:cNvSpPr>
+          <p:nvPr>
+            <p:ph type="sldImg" idx="2"/>
+          </p:nvPr>
+        </p:nvSpPr>
+        <p:spPr/>
+      </p:sp>
+      <p:sp>
+        <p:nvSpPr>
+          <p:cNvPr id="3" name="Notes Placeholder 2"/>
+          <p:cNvSpPr>
+            <a:spLocks noGrp="1"/>
+          </p:cNvSpPr>
+          <p:nvPr>
+            <p:ph type="body" idx="3" sz="quarter"/>
+          </p:nvPr>
+        </p:nvSpPr>
+        <p:spPr/>
+        <p:txBody>
+          <a:bodyPr/>
+          <a:lstStyle/>
+          <a:p>
+            <a:r>
+              <a:t>None of this is sacred without safety. Sacred means you're never pushed, never performing, never abandoning yourself. Your yes is real because your no is allowed. Consent, first with yourself, is the beginning of anything holy. Everything tonight is an invitation: take what's yours, leave the rest.</a:t>
+            </a:r>
+          </a:p>
+        </p:txBody>
+      </p:sp>
+      <p:sp>
+        <p:nvSpPr>
+          <p:cNvPr id="4" name="Slide Number Placeholder 3"/>
+          <p:cNvSpPr>
+            <a:spLocks noGrp="1"/>
+          </p:cNvSpPr>
+          <p:nvPr>
+            <p:ph type="sldNum" idx="5" sz="quarter"/>
+          </p:nvPr>
+        </p:nvSpPr>
+        <p:spPr/>
+      </p:sp>
+    </p:spTree>
+  </p:cSld>
+  <p:clrMapOvr>
+    <a:masterClrMapping/>
+  </p:clrMapOvr>
+</p:notes>
 </file>
 
 <file path=ppt/slideLayouts/slideLayout1.xml><?xml version="1.0" encoding="utf-8"?>
@@ -10307,4 +12967,324 @@
   </a:objectDefaults>
   <a:extraClrSchemeLst/>
 </a:theme>
+</file>
+
+<file path=ppt/theme/theme2.xml><?xml version="1.0" encoding="utf-8"?>
+<a:theme xmlns:a="http://schemas.openxmlformats.org/drawingml/2006/main" name="Office Theme">
+  <a:themeElements>
+    <a:clrScheme name="Office">
+      <a:dk1>
+        <a:sysClr val="windowText" lastClr="000000"/>
+      </a:dk1>
+      <a:lt1>
+        <a:sysClr val="window" lastClr="FFFFFF"/>
+      </a:lt1>
+      <a:dk2>
+        <a:srgbClr val="1F497D"/>
+      </a:dk2>
+      <a:lt2>
+        <a:srgbClr val="EEECE1"/>
+      </a:lt2>
+      <a:accent1>
+        <a:srgbClr val="4F81BD"/>
+      </a:accent1>
+      <a:accent2>
+        <a:srgbClr val="C0504D"/>
+      </a:accent2>
+      <a:accent3>
+        <a:srgbClr val="9BBB59"/>
+      </a:accent3>
+      <a:accent4>
+        <a:srgbClr val="8064A2"/>
+      </a:accent4>
+      <a:accent5>
+        <a:srgbClr val="4BACC6"/>
+      </a:accent5>
+      <a:accent6>
+        <a:srgbClr val="F79646"/>
+      </a:accent6>
+      <a:hlink>
+        <a:srgbClr val="0000FF"/>
+      </a:hlink>
+      <a:folHlink>
+        <a:srgbClr val="800080"/>
+      </a:folHlink>
+    </a:clrScheme>
+    <a:fontScheme name="Office">
+      <a:majorFont>
+        <a:latin typeface="Calibri"/>
+        <a:ea typeface=""/>
+        <a:cs typeface=""/>
+        <a:font script="Jpan" typeface="ＭＳ Ｐゴシック"/>
+        <a:font script="Hang" typeface="맑은 고딕"/>
+        <a:font script="Hans" typeface="宋体"/>
+        <a:font script="Hant" typeface="新細明體"/>
+        <a:font script="Arab" typeface="Times New Roman"/>
+        <a:font script="Hebr" typeface="Times New Roman"/>
+        <a:font script="Thai" typeface="Angsana New"/>
+        <a:font script="Ethi" typeface="Nyala"/>
+        <a:font script="Beng" typeface="Vrinda"/>
+        <a:font script="Gujr" typeface="Shruti"/>
+        <a:font script="Khmr" typeface="MoolBoran"/>
+        <a:font script="Knda" typeface="Tunga"/>
+        <a:font script="Guru" typeface="Raavi"/>
+        <a:font script="Cans" typeface="Euphemia"/>
+        <a:font script="Cher" typeface="Plantagenet Cherokee"/>
+        <a:font script="Yiii" typeface="Microsoft Yi Baiti"/>
+        <a:font script="Tibt" typeface="Microsoft Himalaya"/>
+        <a:font script="Thaa" typeface="MV Boli"/>
+        <a:font script="Deva" typeface="Mangal"/>
+        <a:font script="Telu" typeface="Gautami"/>
+        <a:font script="Taml" typeface="Latha"/>
+        <a:font script="Syrc" typeface="Estrangelo Edessa"/>
+        <a:font script="Orya" typeface="Kalinga"/>
+        <a:font script="Mlym" typeface="Kartika"/>
+        <a:font script="Laoo" typeface="DokChampa"/>
+        <a:font script="Sinh" typeface="Iskoola Pota"/>
+        <a:font script="Mong" typeface="Mongolian Baiti"/>
+        <a:font script="Viet" typeface="Times New Roman"/>
+        <a:font script="Uigh" typeface="Microsoft Uighur"/>
+        <a:font script="Geor" typeface="Sylfaen"/>
+      </a:majorFont>
+      <a:minorFont>
+        <a:latin typeface="Calibri"/>
+        <a:ea typeface=""/>
+        <a:cs typeface=""/>
+        <a:font script="Jpan" typeface="ＭＳ Ｐゴシック"/>
+        <a:font script="Hang" typeface="맑은 고딕"/>
+        <a:font script="Hans" typeface="宋体"/>
+        <a:font script="Hant" typeface="新細明體"/>
+        <a:font script="Arab" typeface="Arial"/>
+        <a:font script="Hebr" typeface="Arial"/>
+        <a:font script="Thai" typeface="Cordia New"/>
+        <a:font script="Ethi" typeface="Nyala"/>
+        <a:font script="Beng" typeface="Vrinda"/>
+        <a:font script="Gujr" typeface="Shruti"/>
+        <a:font script="Khmr" typeface="DaunPenh"/>
+        <a:font script="Knda" typeface="Tunga"/>
+        <a:font script="Guru" typeface="Raavi"/>
+        <a:font script="Cans" typeface="Euphemia"/>
+        <a:font script="Cher" typeface="Plantagenet Cherokee"/>
+        <a:font script="Yiii" typeface="Microsoft Yi Baiti"/>
+        <a:font script="Tibt" typeface="Microsoft Himalaya"/>
+        <a:font script="Thaa" typeface="MV Boli"/>
+        <a:font script="Deva" typeface="Mangal"/>
+        <a:font script="Telu" typeface="Gautami"/>
+        <a:font script="Taml" typeface="Latha"/>
+        <a:font script="Syrc" typeface="Estrangelo Edessa"/>
+        <a:font script="Orya" typeface="Kalinga"/>
+        <a:font script="Mlym" typeface="Kartika"/>
+        <a:font script="Laoo" typeface="DokChampa"/>
+        <a:font script="Sinh" typeface="Iskoola Pota"/>
+        <a:font script="Mong" typeface="Mongolian Baiti"/>
+        <a:font script="Viet" typeface="Arial"/>
+        <a:font script="Uigh" typeface="Microsoft Uighur"/>
+        <a:font script="Geor" typeface="Sylfaen"/>
+      </a:minorFont>
+    </a:fontScheme>
+    <a:fmtScheme name="Office">
+      <a:fillStyleLst>
+        <a:solidFill>
+          <a:schemeClr val="phClr"/>
+        </a:solidFill>
+        <a:gradFill rotWithShape="1">
+          <a:gsLst>
+            <a:gs pos="0">
+              <a:schemeClr val="phClr">
+                <a:tint val="50000"/>
+                <a:satMod val="300000"/>
+              </a:schemeClr>
+            </a:gs>
+            <a:gs pos="35000">
+              <a:schemeClr val="phClr">
+                <a:tint val="37000"/>
+                <a:satMod val="300000"/>
+              </a:schemeClr>
+            </a:gs>
+            <a:gs pos="100000">
+              <a:schemeClr val="phClr">
+                <a:tint val="15000"/>
+                <a:satMod val="350000"/>
+              </a:schemeClr>
+            </a:gs>
+          </a:gsLst>
+          <a:lin ang="16200000" scaled="1"/>
+        </a:gradFill>
+        <a:gradFill rotWithShape="1">
+          <a:gsLst>
+            <a:gs pos="0">
+              <a:schemeClr val="phClr">
+                <a:tint val="100000"/>
+                <a:shade val="100000"/>
+                <a:satMod val="130000"/>
+              </a:schemeClr>
+            </a:gs>
+            <a:gs pos="100000">
+              <a:schemeClr val="phClr">
+                <a:tint val="50000"/>
+                <a:shade val="100000"/>
+                <a:satMod val="350000"/>
+              </a:schemeClr>
+            </a:gs>
+          </a:gsLst>
+          <a:lin ang="16200000" scaled="0"/>
+        </a:gradFill>
+      </a:fillStyleLst>
+      <a:lnStyleLst>
+        <a:ln w="9525" cap="flat" cmpd="sng" algn="ctr">
+          <a:solidFill>
+            <a:schemeClr val="phClr">
+              <a:shade val="95000"/>
+              <a:satMod val="105000"/>
+            </a:schemeClr>
+          </a:solidFill>
+          <a:prstDash val="solid"/>
+        </a:ln>
+        <a:ln w="25400" cap="flat" cmpd="sng" algn="ctr">
+          <a:solidFill>
+            <a:schemeClr val="phClr"/>
+          </a:solidFill>
+          <a:prstDash val="solid"/>
+        </a:ln>
+        <a:ln w="38100" cap="flat" cmpd="sng" algn="ctr">
+          <a:solidFill>
+            <a:schemeClr val="phClr"/>
+          </a:solidFill>
+          <a:prstDash val="solid"/>
+        </a:ln>
+      </a:lnStyleLst>
+      <a:effectStyleLst>
+        <a:effectStyle>
+          <a:effectLst>
+            <a:outerShdw blurRad="40000" dist="20000" dir="5400000" rotWithShape="0">
+              <a:srgbClr val="000000">
+                <a:alpha val="38000"/>
+              </a:srgbClr>
+            </a:outerShdw>
+          </a:effectLst>
+        </a:effectStyle>
+        <a:effectStyle>
+          <a:effectLst>
+            <a:outerShdw blurRad="40000" dist="23000" dir="5400000" rotWithShape="0">
+              <a:srgbClr val="000000">
+                <a:alpha val="35000"/>
+              </a:srgbClr>
+            </a:outerShdw>
+          </a:effectLst>
+        </a:effectStyle>
+        <a:effectStyle>
+          <a:effectLst>
+            <a:outerShdw blurRad="40000" dist="23000" dir="5400000" rotWithShape="0">
+              <a:srgbClr val="000000">
+                <a:alpha val="35000"/>
+              </a:srgbClr>
+            </a:outerShdw>
+          </a:effectLst>
+          <a:scene3d>
+            <a:camera prst="orthographicFront">
+              <a:rot lat="0" lon="0" rev="0"/>
+            </a:camera>
+            <a:lightRig rig="threePt" dir="t">
+              <a:rot lat="0" lon="0" rev="1200000"/>
+            </a:lightRig>
+          </a:scene3d>
+          <a:sp3d>
+            <a:bevelT w="63500" h="25400"/>
+          </a:sp3d>
+        </a:effectStyle>
+      </a:effectStyleLst>
+      <a:bgFillStyleLst>
+        <a:solidFill>
+          <a:schemeClr val="phClr"/>
+        </a:solidFill>
+        <a:gradFill rotWithShape="1">
+          <a:gsLst>
+            <a:gs pos="0">
+              <a:schemeClr val="phClr">
+                <a:tint val="40000"/>
+                <a:satMod val="350000"/>
+              </a:schemeClr>
+            </a:gs>
+            <a:gs pos="40000">
+              <a:schemeClr val="phClr">
+                <a:tint val="45000"/>
+                <a:shade val="99000"/>
+                <a:satMod val="350000"/>
+              </a:schemeClr>
+            </a:gs>
+            <a:gs pos="100000">
+              <a:schemeClr val="phClr">
+                <a:shade val="20000"/>
+                <a:satMod val="255000"/>
+              </a:schemeClr>
+            </a:gs>
+          </a:gsLst>
+          <a:path path="circle">
+            <a:fillToRect l="50000" t="-80000" r="50000" b="180000"/>
+          </a:path>
+        </a:gradFill>
+        <a:gradFill rotWithShape="1">
+          <a:gsLst>
+            <a:gs pos="0">
+              <a:schemeClr val="phClr">
+                <a:tint val="80000"/>
+                <a:satMod val="300000"/>
+              </a:schemeClr>
+            </a:gs>
+            <a:gs pos="100000">
+              <a:schemeClr val="phClr">
+                <a:shade val="30000"/>
+                <a:satMod val="200000"/>
+              </a:schemeClr>
+            </a:gs>
+          </a:gsLst>
+          <a:path path="circle">
+            <a:fillToRect l="50000" t="50000" r="50000" b="50000"/>
+          </a:path>
+        </a:gradFill>
+      </a:bgFillStyleLst>
+    </a:fmtScheme>
+  </a:themeElements>
+  <a:objectDefaults>
+    <a:spDef>
+      <a:spPr/>
+      <a:bodyPr/>
+      <a:lstStyle/>
+      <a:style>
+        <a:lnRef idx="1">
+          <a:schemeClr val="accent1"/>
+        </a:lnRef>
+        <a:fillRef idx="3">
+          <a:schemeClr val="accent1"/>
+        </a:fillRef>
+        <a:effectRef idx="2">
+          <a:schemeClr val="accent1"/>
+        </a:effectRef>
+        <a:fontRef idx="minor">
+          <a:schemeClr val="lt1"/>
+        </a:fontRef>
+      </a:style>
+    </a:spDef>
+    <a:lnDef>
+      <a:spPr/>
+      <a:bodyPr/>
+      <a:lstStyle/>
+      <a:style>
+        <a:lnRef idx="2">
+          <a:schemeClr val="accent1"/>
+        </a:lnRef>
+        <a:fillRef idx="0">
+          <a:schemeClr val="accent1"/>
+        </a:fillRef>
+        <a:effectRef idx="1">
+          <a:schemeClr val="accent1"/>
+        </a:effectRef>
+        <a:fontRef idx="minor">
+          <a:schemeClr val="tx1"/>
+        </a:fontRef>
+      </a:style>
+    </a:lnDef>
+  </a:objectDefaults>
+  <a:extraClrSchemeLst/>
+</a:theme>
 </file>
</xml_diff>